<commit_message>
Written but not read: titles, tips and speaker notes in English
Co-Authored-By: Claude Opus 5.5 <noreply@anthropic.com>
Claude-Session: https://claude.ai/code/session_01XjTEwQ8YdBa1SjcPiYTm9z
</commit_message>
<xml_diff>
--- a/silent-letters/Written-Not-Read.pptx
+++ b/silent-letters/Written-Not-Read.pptx
@@ -521,7 +521,7 @@
           <a:p>
             <a:r>
               <a:rPr lang="en-US" dirty="0"/>
-              <a:t>في المصحف حروف تُكتب ولا تُقرأ. ثلاث علامات تدلنا: الدائرة الصغيرة «۟» فوق الحرف (لا يُقرأ أبداً)، والصفر المستطيل القائم «۠» (يُقرأ عند الوقف فقط)، وحروف بلا علامة تسقط عند الوصل (مثل همزة الوصل واللام الشمسية).</a:t>
+              <a:t>In the Mushaf some letters are written but not pronounced. Three signs tell you: a small round circle on a letter (never read), an upright oval zero (read only when you stop on the word), and some letters with no sign at all that drop when you connect to the next word (hamzat al-wasl, the sun lam, a madd letter before a silent letter).</a:t>
             </a:r>
             <a:endParaRPr lang="en-US" dirty="0"/>
           </a:p>
@@ -609,7 +609,7 @@
           <a:p>
             <a:r>
               <a:rPr lang="en-US" dirty="0"/>
-              <a:t>سورة الذاريات 47: «وَٱلسَّمَآءَ بَنَيۡنَٰهَا بِأَيۡي۟دٍ»: نقرأ «بِأَيۡدٍ»، الياء الثانية لا تُقرأ.</a:t>
+              <a:t>Surat adh-Dhariyat 47: was-samaa'a banaynaahaa bi-aydin. The second yaa is not read.</a:t>
             </a:r>
             <a:endParaRPr lang="en-US" dirty="0"/>
           </a:p>
@@ -697,7 +697,7 @@
           <a:p>
             <a:r>
               <a:rPr lang="en-US" dirty="0"/>
-              <a:t>«أَنَا۠»: إذا وصلناها بما بعدها نقرأ «أَنَ» بلا ألف (أَنَ نَذِيرٌ)، وإذا وقفنا عليها نقرأ «أَنَا» بالألف. (وصلاً: a-na — وقفاً: a-naa)</a:t>
+              <a:t>anaa (I). Joined to the next word, read ana with a short a (ana nadheer). Stopping on it, read anaa with the alif. (Connecting: a-na. Stopping: a-naa.)</a:t>
             </a:r>
             <a:endParaRPr lang="en-US" dirty="0"/>
           </a:p>
@@ -785,7 +785,7 @@
           <a:p>
             <a:r>
               <a:rPr lang="en-US" dirty="0"/>
-              <a:t>سورة الكهف 38: «لَّٰكِنَّا۠ هُوَ ٱللَّهُ رَبِّي»: في الوصل «لَٰكِنَّ هُوَ»، وعند الوقف «لَٰكِنَّا». (وصلاً: laa-kin-na — وقفاً: laa-kin-naa)</a:t>
+              <a:t>Surat al-Kahf 38. Connecting: laakinna huwa. Stopping: laakinnaa. (Connecting: laa-kin-na. Stopping: laa-kin-naa.)</a:t>
             </a:r>
             <a:endParaRPr lang="en-US" dirty="0"/>
           </a:p>
@@ -873,7 +873,7 @@
           <a:p>
             <a:r>
               <a:rPr lang="en-US" dirty="0"/>
-              <a:t>سورة الأحزاب 10: «وَتَظُنُّونَ بِٱللَّهِ ٱلظُّنُونَا۠». في الوصل بلا ألف، وعند الوقف بالألف. ومثلها «ٱلرَّسُولَا۠» و«ٱلسَّبِيلَا۠» في الأحزاب. (وصلاً: adh-dhu-noo-na — وقفاً: adh-dhu-noo-naa)</a:t>
+              <a:t>Surat al-Ahzab 10. Connecting without the alif, stopping with it. The same in ar-rasoolaa and as-sabeelaa in al-Ahzab. (Connecting: adh-dhu-noo-na. Stopping: adh-dhu-noo-naa.)</a:t>
             </a:r>
             <a:endParaRPr lang="en-US" dirty="0"/>
           </a:p>
@@ -961,7 +961,7 @@
           <a:p>
             <a:r>
               <a:rPr lang="en-US" dirty="0"/>
-              <a:t>سورة الأحزاب 67: «فَأَضَلُّونَا ٱلسَّبِيلَا۠». (وصلاً: as-sa-bee-la — وقفاً: as-sa-bee-laa)</a:t>
+              <a:t>Surat al-Ahzab 67: fa-adalloonas-sabeelaa. (Connecting: as-sa-bee-la. Stopping: as-sa-bee-laa.)</a:t>
             </a:r>
             <a:endParaRPr lang="en-US" dirty="0"/>
           </a:p>
@@ -1049,7 +1049,7 @@
           <a:p>
             <a:r>
               <a:rPr lang="en-US" dirty="0"/>
-              <a:t>همزة الوصل تُكتب دائماً، لكنها لا تُقرأ إذا وصلنا الكلمة بما قبلها. (راجع ملف همزة الوصل.)</a:t>
+              <a:t>The connecting hamza is always written, but not read when the word is joined to the word before it (see the Hamzat al-Wasl lesson).</a:t>
             </a:r>
             <a:endParaRPr lang="en-US" dirty="0"/>
           </a:p>
@@ -1137,7 +1137,7 @@
           <a:p>
             <a:r>
               <a:rPr lang="en-US" dirty="0"/>
-              <a:t>اللام بلا علامة والحرف بعدها مشدد: لا تُقرأ. (راجع ملف اللام الشمسية والقمرية.)</a:t>
+              <a:t>The lam has no mark and the next letter has a shaddah, so the lam is not read (see the Sun and Moon Letters lesson).</a:t>
             </a:r>
             <a:endParaRPr lang="en-US" dirty="0"/>
           </a:p>
@@ -1225,7 +1225,7 @@
           <a:p>
             <a:r>
               <a:rPr lang="en-US" dirty="0"/>
-              <a:t>إذا جاء بعد حرف المد حرف ساكن في الكلمة التالية، سقط حرف المد في النطق: «فِي ٱلۡأَرۡضِ» نقرأ «فِلۡأَرۡضِ».</a:t>
+              <a:t>When a word ends with a madd letter and the next word begins with a silent letter, the madd letter is not pronounced: fil-ardi, not fee al-ardi.</a:t>
             </a:r>
             <a:endParaRPr lang="en-US" dirty="0"/>
           </a:p>
@@ -1313,7 +1313,7 @@
           <a:p>
             <a:r>
               <a:rPr lang="en-US" dirty="0"/>
-              <a:t>سورة فاطر 34: «وَقَالُوا۟ ٱلۡحَمۡدُ لِلَّهِ»: الألف لا تُقرأ أبداً (الدائرة)، والواو تسقط في الوصل لأن بعدها لاماً ساكنة.</a:t>
+              <a:t>Surat Fatir 34: wa qaalul-hamdu lillaah. The alif is never read (small circle), and the waw drops when connecting because a silent lam follows.</a:t>
             </a:r>
             <a:endParaRPr lang="en-US" dirty="0"/>
           </a:p>
@@ -1401,7 +1401,7 @@
           <a:p>
             <a:r>
               <a:rPr lang="en-US" dirty="0"/>
-              <a:t>ألف تنوين الفتح لا تُقرأ في الوصل (نقرأ التنوين نوناً ساكنة)، وعند الوقف يذهب التنوين ونقرأ ألفاً مدية حركتين: «عَلِيمَا». (وصلاً: 'a-lee-man — وقفاً: 'a-lee-maa)</a:t>
+              <a:t>The alif after fathatan is not read when connecting (we say the tanween as a noon). When we stop, the tanween goes and we read a long alif of two counts: 'aleemaa. (Connecting: 'a-lee-man. Stopping: 'a-lee-maa.)</a:t>
             </a:r>
             <a:endParaRPr lang="en-US" dirty="0"/>
           </a:p>
@@ -1489,7 +1489,7 @@
           <a:p>
             <a:r>
               <a:rPr lang="en-US" dirty="0"/>
-              <a:t>بعد واو الجماعة تُكتب ألف عليها دائرة صغيرة. لا تُقرأ في الوصل ولا في الوقف: «قَالُوا۟» نقرأ «قَالُو».</a:t>
+              <a:t>After the plural waw (they) an alif is written with a small circle on it. It is never read, whether you connect or stop: qaaloo.</a:t>
             </a:r>
             <a:endParaRPr lang="en-US" dirty="0"/>
           </a:p>
@@ -1577,7 +1577,7 @@
           <a:p>
             <a:r>
               <a:rPr lang="en-US" dirty="0"/>
-              <a:t>في «ٱلصَّلَوٰةَ» و«ٱلزَّكَوٰةَ» و«ٱلۡحَيَوٰةَ» تُكتب واو فوقها ألف خنجرية: العبرة بالألف الصغيرة، فلا ننطق الواو.</a:t>
+              <a:t>In as-salaah, az-zakaah and al-hayaah a waw is written with a small (dagger) alif on it. Follow the small alif and do not pronounce the waw.</a:t>
             </a:r>
             <a:endParaRPr lang="en-US" dirty="0"/>
           </a:p>
@@ -1665,7 +1665,7 @@
           <a:p>
             <a:r>
               <a:rPr lang="en-US" dirty="0"/>
-              <a:t>«ءَامَنُوا۟»: الألف الأخيرة لا تُقرأ. نقف على الواو بمدٍّ طبيعي: آمَنُو.</a:t>
+              <a:t>aamanoo (they believed). The last alif is not read; the word ends on a long oo.</a:t>
             </a:r>
             <a:endParaRPr lang="en-US" dirty="0"/>
           </a:p>
@@ -1753,7 +1753,7 @@
           <a:p>
             <a:r>
               <a:rPr lang="en-US" dirty="0"/>
-              <a:t>«مِا۟ئَةَ» (مئة): الألف بعد الميم لا تُقرأ. لا نقول «مَائة» ولا «مِيئة»، بل «مِئَة».</a:t>
+              <a:t>mi'ah (a hundred). Do not say maa'ah or mee'ah. The alif after the meem is not read.</a:t>
             </a:r>
             <a:endParaRPr lang="en-US" dirty="0"/>
           </a:p>
@@ -1841,7 +1841,7 @@
           <a:p>
             <a:r>
               <a:rPr lang="en-US" dirty="0"/>
-              <a:t>«مِا۟ئَتَيۡنِ» (مئتين): الألف لا تُقرأ.</a:t>
+              <a:t>mi'atayni (two hundred). The alif is not read.</a:t>
             </a:r>
             <a:endParaRPr lang="en-US" dirty="0"/>
           </a:p>
@@ -1929,7 +1929,7 @@
           <a:p>
             <a:r>
               <a:rPr lang="en-US" dirty="0"/>
-              <a:t>«أُو۟لَٰٓئِكَ»: الواو عليها دائرة صغيرة فلا تُقرأ: «أُلَٰٓئِك». والألف الخنجرية بعد اللام تُمد لأن بعدها همزة.</a:t>
+              <a:t>ulaa'ika (those). The waw carries a small circle, so it is not read. The small alif after the lam is stretched because a hamza follows it.</a:t>
             </a:r>
             <a:endParaRPr lang="en-US" dirty="0"/>
           </a:p>
@@ -2017,7 +2017,7 @@
           <a:p>
             <a:r>
               <a:rPr lang="en-US" dirty="0"/>
-              <a:t>«أُو۟لُوا۟ ٱلۡأَلۡبَٰبِ»: الواو الأولى لا تُقرأ، والألف بعد الواو الثانية لا تُقرأ، والواو الثانية تسقط في الوصل لأن بعدها ساكناً: «أُلُلۡ أَلۡبَاب».</a:t>
+              <a:t>ulul-albaab (people of understanding). The first waw is not read, the alif after the second waw is not read, and the second waw drops when connecting because a silent lam follows.</a:t>
             </a:r>
             <a:endParaRPr lang="en-US" dirty="0"/>
           </a:p>
@@ -2105,7 +2105,7 @@
           <a:p>
             <a:r>
               <a:rPr lang="en-US" dirty="0"/>
-              <a:t>سورة الكهف 23: «وَلَا تَقُولَنَّ لِشَا۟يۡءٍ»: نقرأ «لِشَيۡءٍ».</a:t>
+              <a:t>Surat al-Kahf 23: wa laa taqoolanna li-shay'in. Read li-shay'in, without the alif.</a:t>
             </a:r>
             <a:endParaRPr lang="en-US" dirty="0"/>
           </a:p>
@@ -2193,7 +2193,7 @@
           <a:p>
             <a:r>
               <a:rPr lang="en-US" dirty="0"/>
-              <a:t>سورة هود 68: «أَلَآ إِنَّ ثَمُودَا۟ كَفَرُوا۟ رَبَّهُمۡ»: نقرأ «ثَمُودَ» بلا ألف، وصلاً ووقفاً.</a:t>
+              <a:t>Surat Hud 68: alaa inna Thamooda kafaroo rabbahum. Read Thamooda without an alif, connecting or stopping.</a:t>
             </a:r>
             <a:endParaRPr lang="en-US" dirty="0"/>
           </a:p>
@@ -2928,7 +2928,7 @@
         </p:nvSpPr>
         <p:spPr>
           <a:xfrm>
-            <a:off x="365760" y="903097"/>
+            <a:off x="365760" y="872744"/>
             <a:ext cx="8412480" cy="530352"/>
           </a:xfrm>
           <a:prstGeom prst="rect">
@@ -2941,21 +2941,21 @@
           <a:bodyPr wrap="none" lIns="0" tIns="0" rIns="0" bIns="0" rtlCol="0" anchor="ctr"/>
           <a:lstStyle/>
           <a:p>
-            <a:pPr rtl="1" algn="ctr" indent="0" marL="0">
+            <a:pPr algn="ctr" indent="0" marL="0">
               <a:buNone/>
             </a:pPr>
             <a:r>
-              <a:rPr lang="ar-SA" altLang="en-US" sz="2200" dirty="0">
+              <a:rPr lang="en-US" sz="2300" b="1" dirty="0">
                 <a:solidFill>
                   <a:srgbClr val="FFFFFF"/>
                 </a:solidFill>
-                <a:latin typeface="Traditional Arabic" pitchFamily="34" charset="0"/>
-                <a:ea typeface="Traditional Arabic" pitchFamily="34" charset="-122"/>
-                <a:cs typeface="Traditional Arabic" pitchFamily="34" charset="-120"/>
+                <a:latin typeface="Arial" pitchFamily="34" charset="0"/>
+                <a:ea typeface="Arial" pitchFamily="34" charset="-122"/>
+                <a:cs typeface="Arial" pitchFamily="34" charset="-120"/>
               </a:rPr>
-              <a:t>حروف تُكتب ولا تُقرأ: كيف نعرفها؟</a:t>
+              <a:t>Letters that are written but not read: how to spot them</a:t>
             </a:r>
-            <a:endParaRPr lang="ar-SA" sz="2200" dirty="0"/>
+            <a:endParaRPr lang="en-US" sz="2300" dirty="0"/>
           </a:p>
         </p:txBody>
       </p:sp>
@@ -3074,7 +3074,7 @@
         </p:nvSpPr>
         <p:spPr>
           <a:xfrm>
-            <a:off x="6172200" y="3362789"/>
+            <a:off x="6172200" y="3344164"/>
             <a:ext cx="2606040" cy="685800"/>
           </a:xfrm>
           <a:prstGeom prst="rect">
@@ -3087,21 +3087,21 @@
           <a:bodyPr wrap="none" lIns="0" tIns="0" rIns="0" bIns="0" rtlCol="0" anchor="ctr"/>
           <a:lstStyle/>
           <a:p>
-            <a:pPr rtl="1" algn="ctr" indent="0" marL="0">
+            <a:pPr algn="ctr" indent="0" marL="0">
               <a:buNone/>
             </a:pPr>
             <a:r>
-              <a:rPr lang="ar-SA" altLang="en-US" sz="2900" dirty="0">
+              <a:rPr lang="en-US" sz="2600" b="1" dirty="0">
                 <a:solidFill>
                   <a:srgbClr val="FFFFFF"/>
                 </a:solidFill>
-                <a:latin typeface="Traditional Arabic" pitchFamily="34" charset="0"/>
-                <a:ea typeface="Traditional Arabic" pitchFamily="34" charset="-122"/>
-                <a:cs typeface="Traditional Arabic" pitchFamily="34" charset="-120"/>
+                <a:latin typeface="Arial" pitchFamily="34" charset="0"/>
+                <a:ea typeface="Arial" pitchFamily="34" charset="-122"/>
+                <a:cs typeface="Arial" pitchFamily="34" charset="-120"/>
               </a:rPr>
-              <a:t>لا تُقرأ أبداً</a:t>
+              <a:t>Never read</a:t>
             </a:r>
-            <a:endParaRPr lang="ar-SA" sz="2900" dirty="0"/>
+            <a:endParaRPr lang="en-US" sz="2600" dirty="0"/>
           </a:p>
         </p:txBody>
       </p:sp>
@@ -3220,7 +3220,7 @@
         </p:nvSpPr>
         <p:spPr>
           <a:xfrm>
-            <a:off x="3268980" y="3347085"/>
+            <a:off x="3268980" y="3318256"/>
             <a:ext cx="2606040" cy="685800"/>
           </a:xfrm>
           <a:prstGeom prst="rect">
@@ -3233,21 +3233,21 @@
           <a:bodyPr wrap="none" lIns="0" tIns="0" rIns="0" bIns="0" rtlCol="0" anchor="ctr"/>
           <a:lstStyle/>
           <a:p>
-            <a:pPr rtl="1" algn="ctr" indent="0" marL="0">
+            <a:pPr algn="ctr" indent="0" marL="0">
               <a:buNone/>
             </a:pPr>
             <a:r>
-              <a:rPr lang="ar-SA" altLang="en-US" sz="3000" dirty="0">
+              <a:rPr lang="en-US" sz="1900" b="1" dirty="0">
                 <a:solidFill>
                   <a:srgbClr val="FFFFFF"/>
                 </a:solidFill>
-                <a:latin typeface="Traditional Arabic" pitchFamily="34" charset="0"/>
-                <a:ea typeface="Traditional Arabic" pitchFamily="34" charset="-122"/>
-                <a:cs typeface="Traditional Arabic" pitchFamily="34" charset="-120"/>
+                <a:latin typeface="Arial" pitchFamily="34" charset="0"/>
+                <a:ea typeface="Arial" pitchFamily="34" charset="-122"/>
+                <a:cs typeface="Arial" pitchFamily="34" charset="-120"/>
               </a:rPr>
-              <a:t>تُقرأ عند الوقف</a:t>
+              <a:t>Read when stopping</a:t>
             </a:r>
-            <a:endParaRPr lang="ar-SA" sz="3000" dirty="0"/>
+            <a:endParaRPr lang="en-US" sz="1900" dirty="0"/>
           </a:p>
         </p:txBody>
       </p:sp>
@@ -3352,7 +3352,7 @@
         </p:nvSpPr>
         <p:spPr>
           <a:xfrm>
-            <a:off x="365760" y="3275495"/>
+            <a:off x="365760" y="3323336"/>
             <a:ext cx="2606040" cy="685800"/>
           </a:xfrm>
           <a:prstGeom prst="rect">
@@ -3365,21 +3365,21 @@
           <a:bodyPr wrap="none" lIns="0" tIns="0" rIns="0" bIns="0" rtlCol="0" anchor="ctr"/>
           <a:lstStyle/>
           <a:p>
-            <a:pPr rtl="1" algn="ctr" indent="0" marL="0">
+            <a:pPr algn="ctr" indent="0" marL="0">
               <a:buNone/>
             </a:pPr>
             <a:r>
-              <a:rPr lang="ar-SA" altLang="en-US" sz="2700" dirty="0">
+              <a:rPr lang="en-US" sz="1400" b="1" dirty="0">
                 <a:solidFill>
                   <a:srgbClr val="FFFFFF"/>
                 </a:solidFill>
-                <a:latin typeface="Traditional Arabic" pitchFamily="34" charset="0"/>
-                <a:ea typeface="Traditional Arabic" pitchFamily="34" charset="-122"/>
-                <a:cs typeface="Traditional Arabic" pitchFamily="34" charset="-120"/>
+                <a:latin typeface="Arial" pitchFamily="34" charset="0"/>
+                <a:ea typeface="Arial" pitchFamily="34" charset="-122"/>
+                <a:cs typeface="Arial" pitchFamily="34" charset="-120"/>
               </a:rPr>
-              <a:t>تسقط في الوصل</a:t>
+              <a:t>Dropped when connecting</a:t>
             </a:r>
-            <a:endParaRPr lang="ar-SA" sz="2700" dirty="0"/>
+            <a:endParaRPr lang="en-US" sz="1400" dirty="0"/>
           </a:p>
         </p:txBody>
       </p:sp>
@@ -4113,7 +4113,7 @@
         </p:nvSpPr>
         <p:spPr>
           <a:xfrm>
-            <a:off x="365760" y="914381"/>
+            <a:off x="365760" y="902716"/>
             <a:ext cx="8412480" cy="530352"/>
           </a:xfrm>
           <a:prstGeom prst="rect">
@@ -4126,21 +4126,21 @@
           <a:bodyPr wrap="none" lIns="0" tIns="0" rIns="0" bIns="0" rtlCol="0" anchor="ctr"/>
           <a:lstStyle/>
           <a:p>
-            <a:pPr rtl="1" algn="ctr" indent="0" marL="0">
+            <a:pPr algn="ctr" indent="0" marL="0">
               <a:buNone/>
             </a:pPr>
             <a:r>
-              <a:rPr lang="ar-SA" altLang="en-US" sz="2100" dirty="0">
+              <a:rPr lang="en-US" sz="2600" b="1" dirty="0">
                 <a:solidFill>
                   <a:srgbClr val="FFFFFF"/>
                 </a:solidFill>
-                <a:latin typeface="Traditional Arabic" pitchFamily="34" charset="0"/>
-                <a:ea typeface="Traditional Arabic" pitchFamily="34" charset="-122"/>
-                <a:cs typeface="Traditional Arabic" pitchFamily="34" charset="-120"/>
+                <a:latin typeface="Arial" pitchFamily="34" charset="0"/>
+                <a:ea typeface="Arial" pitchFamily="34" charset="-122"/>
+                <a:cs typeface="Arial" pitchFamily="34" charset="-120"/>
               </a:rPr>
-              <a:t>الدائرة الصغيرة: لا تُقرأ أبداً</a:t>
+              <a:t>Small circle: never read</a:t>
             </a:r>
-            <a:endParaRPr lang="ar-SA" sz="2100" dirty="0"/>
+            <a:endParaRPr lang="en-US" sz="2600" dirty="0"/>
           </a:p>
         </p:txBody>
       </p:sp>
@@ -4403,7 +4403,7 @@
         </p:nvSpPr>
         <p:spPr>
           <a:xfrm>
-            <a:off x="365760" y="3577785"/>
+            <a:off x="365760" y="3539744"/>
             <a:ext cx="8412480" cy="685800"/>
           </a:xfrm>
           <a:prstGeom prst="rect">
@@ -4416,21 +4416,21 @@
           <a:bodyPr wrap="none" lIns="0" tIns="0" rIns="0" bIns="0" rtlCol="0" anchor="ctr"/>
           <a:lstStyle/>
           <a:p>
-            <a:pPr rtl="1" algn="ctr" indent="0" marL="0">
+            <a:pPr algn="ctr" indent="0" marL="0">
               <a:buNone/>
             </a:pPr>
             <a:r>
-              <a:rPr lang="ar-SA" altLang="en-US" sz="2400" dirty="0">
+              <a:rPr lang="en-US" sz="2600" b="1" dirty="0">
                 <a:solidFill>
                   <a:srgbClr val="FFFFFF"/>
                 </a:solidFill>
-                <a:latin typeface="Traditional Arabic" pitchFamily="34" charset="0"/>
-                <a:ea typeface="Traditional Arabic" pitchFamily="34" charset="-122"/>
-                <a:cs typeface="Traditional Arabic" pitchFamily="34" charset="-120"/>
+                <a:latin typeface="Arial" pitchFamily="34" charset="0"/>
+                <a:ea typeface="Arial" pitchFamily="34" charset="-122"/>
+                <a:cs typeface="Arial" pitchFamily="34" charset="-120"/>
               </a:rPr>
-              <a:t>الياء الثانية في «بِأَيۡي۟دٍ» لا تُقرأ</a:t>
+              <a:t>The second yaa of bi-aydin is not read</a:t>
             </a:r>
-            <a:endParaRPr lang="ar-SA" sz="2400" dirty="0"/>
+            <a:endParaRPr lang="en-US" sz="2600" dirty="0"/>
           </a:p>
         </p:txBody>
       </p:sp>
@@ -5021,7 +5021,7 @@
         </p:nvSpPr>
         <p:spPr>
           <a:xfrm>
-            <a:off x="365760" y="903097"/>
+            <a:off x="365760" y="870712"/>
             <a:ext cx="8412480" cy="530352"/>
           </a:xfrm>
           <a:prstGeom prst="rect">
@@ -5034,21 +5034,21 @@
           <a:bodyPr wrap="none" lIns="0" tIns="0" rIns="0" bIns="0" rtlCol="0" anchor="ctr"/>
           <a:lstStyle/>
           <a:p>
-            <a:pPr rtl="1" algn="ctr" indent="0" marL="0">
+            <a:pPr algn="ctr" indent="0" marL="0">
               <a:buNone/>
             </a:pPr>
             <a:r>
-              <a:rPr lang="ar-SA" altLang="en-US" sz="2200" dirty="0">
+              <a:rPr lang="en-US" sz="2500" b="1" dirty="0">
                 <a:solidFill>
                   <a:srgbClr val="FFFFFF"/>
                 </a:solidFill>
-                <a:latin typeface="Traditional Arabic" pitchFamily="34" charset="0"/>
-                <a:ea typeface="Traditional Arabic" pitchFamily="34" charset="-122"/>
-                <a:cs typeface="Traditional Arabic" pitchFamily="34" charset="-120"/>
+                <a:latin typeface="Arial" pitchFamily="34" charset="0"/>
+                <a:ea typeface="Arial" pitchFamily="34" charset="-122"/>
+                <a:cs typeface="Arial" pitchFamily="34" charset="-120"/>
               </a:rPr>
-              <a:t>الصفر المستطيل: تُقرأ عند الوقف فقط</a:t>
+              <a:t>Upright oval: read only when you stop</a:t>
             </a:r>
-            <a:endParaRPr lang="ar-SA" sz="2200" dirty="0"/>
+            <a:endParaRPr lang="en-US" sz="2500" dirty="0"/>
           </a:p>
         </p:txBody>
       </p:sp>
@@ -5193,7 +5193,7 @@
         <p:spPr>
           <a:xfrm>
             <a:off x="457200" y="1664208"/>
-            <a:ext cx="914400" cy="672084"/>
+            <a:ext cx="1325880" cy="672084"/>
           </a:xfrm>
           <a:prstGeom prst="roundRect">
             <a:avLst>
@@ -5219,8 +5219,8 @@
         </p:nvSpPr>
         <p:spPr>
           <a:xfrm>
-            <a:off x="457200" y="1669253"/>
-            <a:ext cx="914400" cy="672084"/>
+            <a:off x="457200" y="1647952"/>
+            <a:ext cx="1325880" cy="672084"/>
           </a:xfrm>
           <a:prstGeom prst="rect">
             <a:avLst/>
@@ -5232,21 +5232,21 @@
           <a:bodyPr wrap="none" lIns="0" tIns="0" rIns="0" bIns="0" rtlCol="0" anchor="ctr"/>
           <a:lstStyle/>
           <a:p>
-            <a:pPr rtl="1" algn="ctr" indent="0" marL="0">
+            <a:pPr algn="ctr" indent="0" marL="0">
               <a:buNone/>
             </a:pPr>
             <a:r>
-              <a:rPr lang="ar-SA" altLang="en-US" sz="3000" dirty="0">
+              <a:rPr lang="en-US" sz="1600" b="1" dirty="0">
                 <a:solidFill>
                   <a:srgbClr val="FFFFFF"/>
                 </a:solidFill>
-                <a:latin typeface="Traditional Arabic" pitchFamily="34" charset="0"/>
-                <a:ea typeface="Traditional Arabic" pitchFamily="34" charset="-122"/>
-                <a:cs typeface="Traditional Arabic" pitchFamily="34" charset="-120"/>
+                <a:latin typeface="Arial" pitchFamily="34" charset="0"/>
+                <a:ea typeface="Arial" pitchFamily="34" charset="-122"/>
+                <a:cs typeface="Arial" pitchFamily="34" charset="-120"/>
               </a:rPr>
-              <a:t>وصلاً</a:t>
+              <a:t>Connecting</a:t>
             </a:r>
-            <a:endParaRPr lang="ar-SA" sz="3000" dirty="0"/>
+            <a:endParaRPr lang="en-US" sz="1600" dirty="0"/>
           </a:p>
         </p:txBody>
       </p:sp>
@@ -5258,8 +5258,8 @@
         </p:nvSpPr>
         <p:spPr>
           <a:xfrm>
-            <a:off x="1417320" y="1594892"/>
-            <a:ext cx="2743200" cy="891540"/>
+            <a:off x="1828800" y="1594892"/>
+            <a:ext cx="2331720" cy="891540"/>
           </a:xfrm>
           <a:prstGeom prst="rect">
             <a:avLst/>
@@ -5325,7 +5325,7 @@
         <p:spPr>
           <a:xfrm>
             <a:off x="457200" y="2647188"/>
-            <a:ext cx="914400" cy="672084"/>
+            <a:ext cx="1325880" cy="672084"/>
           </a:xfrm>
           <a:prstGeom prst="roundRect">
             <a:avLst>
@@ -5351,8 +5351,8 @@
         </p:nvSpPr>
         <p:spPr>
           <a:xfrm>
-            <a:off x="457200" y="2671547"/>
-            <a:ext cx="914400" cy="672084"/>
+            <a:off x="457200" y="2625852"/>
+            <a:ext cx="1325880" cy="672084"/>
           </a:xfrm>
           <a:prstGeom prst="rect">
             <a:avLst/>
@@ -5364,21 +5364,21 @@
           <a:bodyPr wrap="none" lIns="0" tIns="0" rIns="0" bIns="0" rtlCol="0" anchor="ctr"/>
           <a:lstStyle/>
           <a:p>
-            <a:pPr rtl="1" algn="ctr" indent="0" marL="0">
+            <a:pPr algn="ctr" indent="0" marL="0">
               <a:buNone/>
             </a:pPr>
             <a:r>
-              <a:rPr lang="ar-SA" altLang="en-US" sz="2800" dirty="0">
+              <a:rPr lang="en-US" sz="2100" b="1" dirty="0">
                 <a:solidFill>
                   <a:srgbClr val="FFFFFF"/>
                 </a:solidFill>
-                <a:latin typeface="Traditional Arabic" pitchFamily="34" charset="0"/>
-                <a:ea typeface="Traditional Arabic" pitchFamily="34" charset="-122"/>
-                <a:cs typeface="Traditional Arabic" pitchFamily="34" charset="-120"/>
+                <a:latin typeface="Arial" pitchFamily="34" charset="0"/>
+                <a:ea typeface="Arial" pitchFamily="34" charset="-122"/>
+                <a:cs typeface="Arial" pitchFamily="34" charset="-120"/>
               </a:rPr>
-              <a:t>وقفاً</a:t>
+              <a:t>Stopping</a:t>
             </a:r>
-            <a:endParaRPr lang="ar-SA" sz="2800" dirty="0"/>
+            <a:endParaRPr lang="en-US" sz="2100" dirty="0"/>
           </a:p>
         </p:txBody>
       </p:sp>
@@ -5390,8 +5390,8 @@
         </p:nvSpPr>
         <p:spPr>
           <a:xfrm>
-            <a:off x="1417320" y="2632338"/>
-            <a:ext cx="2743200" cy="891540"/>
+            <a:off x="1828800" y="2632338"/>
+            <a:ext cx="2331720" cy="891540"/>
           </a:xfrm>
           <a:prstGeom prst="rect">
             <a:avLst/>
@@ -5470,7 +5470,7 @@
         </p:nvSpPr>
         <p:spPr>
           <a:xfrm>
-            <a:off x="365760" y="3545243"/>
+            <a:off x="365760" y="3539744"/>
             <a:ext cx="8412480" cy="685800"/>
           </a:xfrm>
           <a:prstGeom prst="rect">
@@ -5483,21 +5483,21 @@
           <a:bodyPr wrap="none" lIns="0" tIns="0" rIns="0" bIns="0" rtlCol="0" anchor="ctr"/>
           <a:lstStyle/>
           <a:p>
-            <a:pPr rtl="1" algn="ctr" indent="0" marL="0">
+            <a:pPr algn="ctr" indent="0" marL="0">
               <a:buNone/>
             </a:pPr>
             <a:r>
-              <a:rPr lang="ar-SA" altLang="en-US" sz="2700" dirty="0">
+              <a:rPr lang="en-US" sz="2600" b="1" dirty="0">
                 <a:solidFill>
                   <a:srgbClr val="FFFFFF"/>
                 </a:solidFill>
-                <a:latin typeface="Traditional Arabic" pitchFamily="34" charset="0"/>
-                <a:ea typeface="Traditional Arabic" pitchFamily="34" charset="-122"/>
-                <a:cs typeface="Traditional Arabic" pitchFamily="34" charset="-120"/>
+                <a:latin typeface="Arial" pitchFamily="34" charset="0"/>
+                <a:ea typeface="Arial" pitchFamily="34" charset="-122"/>
+                <a:cs typeface="Arial" pitchFamily="34" charset="-120"/>
               </a:rPr>
-              <a:t>في الوصل لا نقرأ الألف، وعند الوقف نقرؤها</a:t>
+              <a:t>Connecting: no alif.  Stopping: say the alif</a:t>
             </a:r>
-            <a:endParaRPr lang="ar-SA" sz="2700" dirty="0"/>
+            <a:endParaRPr lang="en-US" sz="2600" dirty="0"/>
           </a:p>
         </p:txBody>
       </p:sp>
@@ -6512,7 +6512,7 @@
         </p:nvSpPr>
         <p:spPr>
           <a:xfrm>
-            <a:off x="365760" y="903097"/>
+            <a:off x="365760" y="870712"/>
             <a:ext cx="8412480" cy="530352"/>
           </a:xfrm>
           <a:prstGeom prst="rect">
@@ -6525,21 +6525,21 @@
           <a:bodyPr wrap="none" lIns="0" tIns="0" rIns="0" bIns="0" rtlCol="0" anchor="ctr"/>
           <a:lstStyle/>
           <a:p>
-            <a:pPr rtl="1" algn="ctr" indent="0" marL="0">
+            <a:pPr algn="ctr" indent="0" marL="0">
               <a:buNone/>
             </a:pPr>
             <a:r>
-              <a:rPr lang="ar-SA" altLang="en-US" sz="2200" dirty="0">
+              <a:rPr lang="en-US" sz="2500" b="1" dirty="0">
                 <a:solidFill>
                   <a:srgbClr val="FFFFFF"/>
                 </a:solidFill>
-                <a:latin typeface="Traditional Arabic" pitchFamily="34" charset="0"/>
-                <a:ea typeface="Traditional Arabic" pitchFamily="34" charset="-122"/>
-                <a:cs typeface="Traditional Arabic" pitchFamily="34" charset="-120"/>
+                <a:latin typeface="Arial" pitchFamily="34" charset="0"/>
+                <a:ea typeface="Arial" pitchFamily="34" charset="-122"/>
+                <a:cs typeface="Arial" pitchFamily="34" charset="-120"/>
               </a:rPr>
-              <a:t>الصفر المستطيل: تُقرأ عند الوقف فقط</a:t>
+              <a:t>Upright oval: read only when you stop</a:t>
             </a:r>
-            <a:endParaRPr lang="ar-SA" sz="2200" dirty="0"/>
+            <a:endParaRPr lang="en-US" sz="2500" dirty="0"/>
           </a:p>
         </p:txBody>
       </p:sp>
@@ -6684,7 +6684,7 @@
         <p:spPr>
           <a:xfrm>
             <a:off x="457200" y="1664208"/>
-            <a:ext cx="914400" cy="672084"/>
+            <a:ext cx="1325880" cy="672084"/>
           </a:xfrm>
           <a:prstGeom prst="roundRect">
             <a:avLst>
@@ -6710,8 +6710,8 @@
         </p:nvSpPr>
         <p:spPr>
           <a:xfrm>
-            <a:off x="457200" y="1669253"/>
-            <a:ext cx="914400" cy="672084"/>
+            <a:off x="457200" y="1647952"/>
+            <a:ext cx="1325880" cy="672084"/>
           </a:xfrm>
           <a:prstGeom prst="rect">
             <a:avLst/>
@@ -6723,21 +6723,21 @@
           <a:bodyPr wrap="none" lIns="0" tIns="0" rIns="0" bIns="0" rtlCol="0" anchor="ctr"/>
           <a:lstStyle/>
           <a:p>
-            <a:pPr rtl="1" algn="ctr" indent="0" marL="0">
+            <a:pPr algn="ctr" indent="0" marL="0">
               <a:buNone/>
             </a:pPr>
             <a:r>
-              <a:rPr lang="ar-SA" altLang="en-US" sz="3000" dirty="0">
+              <a:rPr lang="en-US" sz="1600" b="1" dirty="0">
                 <a:solidFill>
                   <a:srgbClr val="FFFFFF"/>
                 </a:solidFill>
-                <a:latin typeface="Traditional Arabic" pitchFamily="34" charset="0"/>
-                <a:ea typeface="Traditional Arabic" pitchFamily="34" charset="-122"/>
-                <a:cs typeface="Traditional Arabic" pitchFamily="34" charset="-120"/>
+                <a:latin typeface="Arial" pitchFamily="34" charset="0"/>
+                <a:ea typeface="Arial" pitchFamily="34" charset="-122"/>
+                <a:cs typeface="Arial" pitchFamily="34" charset="-120"/>
               </a:rPr>
-              <a:t>وصلاً</a:t>
+              <a:t>Connecting</a:t>
             </a:r>
-            <a:endParaRPr lang="ar-SA" sz="3000" dirty="0"/>
+            <a:endParaRPr lang="en-US" sz="1600" dirty="0"/>
           </a:p>
         </p:txBody>
       </p:sp>
@@ -6749,8 +6749,8 @@
         </p:nvSpPr>
         <p:spPr>
           <a:xfrm>
-            <a:off x="1417320" y="1601419"/>
-            <a:ext cx="2743200" cy="891540"/>
+            <a:off x="1828800" y="1601419"/>
+            <a:ext cx="2331720" cy="891540"/>
           </a:xfrm>
           <a:prstGeom prst="rect">
             <a:avLst/>
@@ -6816,7 +6816,7 @@
         <p:spPr>
           <a:xfrm>
             <a:off x="457200" y="2647188"/>
-            <a:ext cx="914400" cy="672084"/>
+            <a:ext cx="1325880" cy="672084"/>
           </a:xfrm>
           <a:prstGeom prst="roundRect">
             <a:avLst>
@@ -6842,8 +6842,8 @@
         </p:nvSpPr>
         <p:spPr>
           <a:xfrm>
-            <a:off x="457200" y="2671547"/>
-            <a:ext cx="914400" cy="672084"/>
+            <a:off x="457200" y="2625852"/>
+            <a:ext cx="1325880" cy="672084"/>
           </a:xfrm>
           <a:prstGeom prst="rect">
             <a:avLst/>
@@ -6855,21 +6855,21 @@
           <a:bodyPr wrap="none" lIns="0" tIns="0" rIns="0" bIns="0" rtlCol="0" anchor="ctr"/>
           <a:lstStyle/>
           <a:p>
-            <a:pPr rtl="1" algn="ctr" indent="0" marL="0">
+            <a:pPr algn="ctr" indent="0" marL="0">
               <a:buNone/>
             </a:pPr>
             <a:r>
-              <a:rPr lang="ar-SA" altLang="en-US" sz="2800" dirty="0">
+              <a:rPr lang="en-US" sz="2100" b="1" dirty="0">
                 <a:solidFill>
                   <a:srgbClr val="FFFFFF"/>
                 </a:solidFill>
-                <a:latin typeface="Traditional Arabic" pitchFamily="34" charset="0"/>
-                <a:ea typeface="Traditional Arabic" pitchFamily="34" charset="-122"/>
-                <a:cs typeface="Traditional Arabic" pitchFamily="34" charset="-120"/>
+                <a:latin typeface="Arial" pitchFamily="34" charset="0"/>
+                <a:ea typeface="Arial" pitchFamily="34" charset="-122"/>
+                <a:cs typeface="Arial" pitchFamily="34" charset="-120"/>
               </a:rPr>
-              <a:t>وقفاً</a:t>
+              <a:t>Stopping</a:t>
             </a:r>
-            <a:endParaRPr lang="ar-SA" sz="2800" dirty="0"/>
+            <a:endParaRPr lang="en-US" sz="2100" dirty="0"/>
           </a:p>
         </p:txBody>
       </p:sp>
@@ -6881,8 +6881,8 @@
         </p:nvSpPr>
         <p:spPr>
           <a:xfrm>
-            <a:off x="1417320" y="2590935"/>
-            <a:ext cx="2743200" cy="891540"/>
+            <a:off x="1828800" y="2590935"/>
+            <a:ext cx="2331720" cy="891540"/>
           </a:xfrm>
           <a:prstGeom prst="rect">
             <a:avLst/>
@@ -6961,7 +6961,7 @@
         </p:nvSpPr>
         <p:spPr>
           <a:xfrm>
-            <a:off x="365760" y="3606952"/>
+            <a:off x="365760" y="3572764"/>
             <a:ext cx="8412480" cy="685800"/>
           </a:xfrm>
           <a:prstGeom prst="rect">
@@ -6974,21 +6974,21 @@
           <a:bodyPr wrap="none" lIns="0" tIns="0" rIns="0" bIns="0" rtlCol="0" anchor="ctr"/>
           <a:lstStyle/>
           <a:p>
-            <a:pPr rtl="1" algn="ctr" indent="0" marL="0">
+            <a:pPr algn="ctr" indent="0" marL="0">
               <a:buNone/>
             </a:pPr>
             <a:r>
-              <a:rPr lang="ar-SA" altLang="en-US" sz="2200" dirty="0">
+              <a:rPr lang="en-US" sz="2600" b="1" dirty="0">
                 <a:solidFill>
                   <a:srgbClr val="FFFFFF"/>
                 </a:solidFill>
-                <a:latin typeface="Traditional Arabic" pitchFamily="34" charset="0"/>
-                <a:ea typeface="Traditional Arabic" pitchFamily="34" charset="-122"/>
-                <a:cs typeface="Traditional Arabic" pitchFamily="34" charset="-120"/>
+                <a:latin typeface="Arial" pitchFamily="34" charset="0"/>
+                <a:ea typeface="Arial" pitchFamily="34" charset="-122"/>
+                <a:cs typeface="Arial" pitchFamily="34" charset="-120"/>
               </a:rPr>
-              <a:t>«لَّٰكِنَّا۠ هُوَ ٱللَّهُ رَبِّي»</a:t>
+              <a:t>From al-Kahf 38: laakinna huwa-llaahu rabbee</a:t>
             </a:r>
-            <a:endParaRPr lang="ar-SA" sz="2200" dirty="0"/>
+            <a:endParaRPr lang="en-US" sz="2600" dirty="0"/>
           </a:p>
         </p:txBody>
       </p:sp>
@@ -7930,7 +7930,7 @@
         </p:nvSpPr>
         <p:spPr>
           <a:xfrm>
-            <a:off x="365760" y="903097"/>
+            <a:off x="365760" y="870712"/>
             <a:ext cx="8412480" cy="530352"/>
           </a:xfrm>
           <a:prstGeom prst="rect">
@@ -7943,21 +7943,21 @@
           <a:bodyPr wrap="none" lIns="0" tIns="0" rIns="0" bIns="0" rtlCol="0" anchor="ctr"/>
           <a:lstStyle/>
           <a:p>
-            <a:pPr rtl="1" algn="ctr" indent="0" marL="0">
+            <a:pPr algn="ctr" indent="0" marL="0">
               <a:buNone/>
             </a:pPr>
             <a:r>
-              <a:rPr lang="ar-SA" altLang="en-US" sz="2200" dirty="0">
+              <a:rPr lang="en-US" sz="2500" b="1" dirty="0">
                 <a:solidFill>
                   <a:srgbClr val="FFFFFF"/>
                 </a:solidFill>
-                <a:latin typeface="Traditional Arabic" pitchFamily="34" charset="0"/>
-                <a:ea typeface="Traditional Arabic" pitchFamily="34" charset="-122"/>
-                <a:cs typeface="Traditional Arabic" pitchFamily="34" charset="-120"/>
+                <a:latin typeface="Arial" pitchFamily="34" charset="0"/>
+                <a:ea typeface="Arial" pitchFamily="34" charset="-122"/>
+                <a:cs typeface="Arial" pitchFamily="34" charset="-120"/>
               </a:rPr>
-              <a:t>الصفر المستطيل: تُقرأ عند الوقف فقط</a:t>
+              <a:t>Upright oval: read only when you stop</a:t>
             </a:r>
-            <a:endParaRPr lang="ar-SA" sz="2200" dirty="0"/>
+            <a:endParaRPr lang="en-US" sz="2500" dirty="0"/>
           </a:p>
         </p:txBody>
       </p:sp>
@@ -8102,7 +8102,7 @@
         <p:spPr>
           <a:xfrm>
             <a:off x="457200" y="1664208"/>
-            <a:ext cx="914400" cy="672084"/>
+            <a:ext cx="1325880" cy="672084"/>
           </a:xfrm>
           <a:prstGeom prst="roundRect">
             <a:avLst>
@@ -8128,8 +8128,8 @@
         </p:nvSpPr>
         <p:spPr>
           <a:xfrm>
-            <a:off x="457200" y="1669253"/>
-            <a:ext cx="914400" cy="672084"/>
+            <a:off x="457200" y="1647952"/>
+            <a:ext cx="1325880" cy="672084"/>
           </a:xfrm>
           <a:prstGeom prst="rect">
             <a:avLst/>
@@ -8141,21 +8141,21 @@
           <a:bodyPr wrap="none" lIns="0" tIns="0" rIns="0" bIns="0" rtlCol="0" anchor="ctr"/>
           <a:lstStyle/>
           <a:p>
-            <a:pPr rtl="1" algn="ctr" indent="0" marL="0">
+            <a:pPr algn="ctr" indent="0" marL="0">
               <a:buNone/>
             </a:pPr>
             <a:r>
-              <a:rPr lang="ar-SA" altLang="en-US" sz="3000" dirty="0">
+              <a:rPr lang="en-US" sz="1600" b="1" dirty="0">
                 <a:solidFill>
                   <a:srgbClr val="FFFFFF"/>
                 </a:solidFill>
-                <a:latin typeface="Traditional Arabic" pitchFamily="34" charset="0"/>
-                <a:ea typeface="Traditional Arabic" pitchFamily="34" charset="-122"/>
-                <a:cs typeface="Traditional Arabic" pitchFamily="34" charset="-120"/>
+                <a:latin typeface="Arial" pitchFamily="34" charset="0"/>
+                <a:ea typeface="Arial" pitchFamily="34" charset="-122"/>
+                <a:cs typeface="Arial" pitchFamily="34" charset="-120"/>
               </a:rPr>
-              <a:t>وصلاً</a:t>
+              <a:t>Connecting</a:t>
             </a:r>
-            <a:endParaRPr lang="ar-SA" sz="3000" dirty="0"/>
+            <a:endParaRPr lang="en-US" sz="1600" dirty="0"/>
           </a:p>
         </p:txBody>
       </p:sp>
@@ -8167,8 +8167,8 @@
         </p:nvSpPr>
         <p:spPr>
           <a:xfrm>
-            <a:off x="1417320" y="1624287"/>
-            <a:ext cx="2743200" cy="891540"/>
+            <a:off x="1828800" y="1624287"/>
+            <a:ext cx="2331720" cy="891540"/>
           </a:xfrm>
           <a:prstGeom prst="rect">
             <a:avLst/>
@@ -8234,7 +8234,7 @@
         <p:spPr>
           <a:xfrm>
             <a:off x="457200" y="2647188"/>
-            <a:ext cx="914400" cy="672084"/>
+            <a:ext cx="1325880" cy="672084"/>
           </a:xfrm>
           <a:prstGeom prst="roundRect">
             <a:avLst>
@@ -8260,8 +8260,8 @@
         </p:nvSpPr>
         <p:spPr>
           <a:xfrm>
-            <a:off x="457200" y="2671547"/>
-            <a:ext cx="914400" cy="672084"/>
+            <a:off x="457200" y="2625852"/>
+            <a:ext cx="1325880" cy="672084"/>
           </a:xfrm>
           <a:prstGeom prst="rect">
             <a:avLst/>
@@ -8273,21 +8273,21 @@
           <a:bodyPr wrap="none" lIns="0" tIns="0" rIns="0" bIns="0" rtlCol="0" anchor="ctr"/>
           <a:lstStyle/>
           <a:p>
-            <a:pPr rtl="1" algn="ctr" indent="0" marL="0">
+            <a:pPr algn="ctr" indent="0" marL="0">
               <a:buNone/>
             </a:pPr>
             <a:r>
-              <a:rPr lang="ar-SA" altLang="en-US" sz="2800" dirty="0">
+              <a:rPr lang="en-US" sz="2100" b="1" dirty="0">
                 <a:solidFill>
                   <a:srgbClr val="FFFFFF"/>
                 </a:solidFill>
-                <a:latin typeface="Traditional Arabic" pitchFamily="34" charset="0"/>
-                <a:ea typeface="Traditional Arabic" pitchFamily="34" charset="-122"/>
-                <a:cs typeface="Traditional Arabic" pitchFamily="34" charset="-120"/>
+                <a:latin typeface="Arial" pitchFamily="34" charset="0"/>
+                <a:ea typeface="Arial" pitchFamily="34" charset="-122"/>
+                <a:cs typeface="Arial" pitchFamily="34" charset="-120"/>
               </a:rPr>
-              <a:t>وقفاً</a:t>
+              <a:t>Stopping</a:t>
             </a:r>
-            <a:endParaRPr lang="ar-SA" sz="2800" dirty="0"/>
+            <a:endParaRPr lang="en-US" sz="2100" dirty="0"/>
           </a:p>
         </p:txBody>
       </p:sp>
@@ -8299,8 +8299,8 @@
         </p:nvSpPr>
         <p:spPr>
           <a:xfrm>
-            <a:off x="1417320" y="2607267"/>
-            <a:ext cx="2743200" cy="891540"/>
+            <a:off x="1828800" y="2607267"/>
+            <a:ext cx="2331720" cy="891540"/>
           </a:xfrm>
           <a:prstGeom prst="rect">
             <a:avLst/>
@@ -8379,7 +8379,7 @@
         </p:nvSpPr>
         <p:spPr>
           <a:xfrm>
-            <a:off x="365760" y="3537356"/>
+            <a:off x="365760" y="3539744"/>
             <a:ext cx="8412480" cy="685800"/>
           </a:xfrm>
           <a:prstGeom prst="rect">
@@ -8392,21 +8392,21 @@
           <a:bodyPr wrap="none" lIns="0" tIns="0" rIns="0" bIns="0" rtlCol="0" anchor="ctr"/>
           <a:lstStyle/>
           <a:p>
-            <a:pPr rtl="1" algn="ctr" indent="0" marL="0">
+            <a:pPr algn="ctr" indent="0" marL="0">
               <a:buNone/>
             </a:pPr>
             <a:r>
-              <a:rPr lang="ar-SA" altLang="en-US" sz="2800" dirty="0">
+              <a:rPr lang="en-US" sz="2600" b="1" dirty="0">
                 <a:solidFill>
                   <a:srgbClr val="FFFFFF"/>
                 </a:solidFill>
-                <a:latin typeface="Traditional Arabic" pitchFamily="34" charset="0"/>
-                <a:ea typeface="Traditional Arabic" pitchFamily="34" charset="-122"/>
-                <a:cs typeface="Traditional Arabic" pitchFamily="34" charset="-120"/>
+                <a:latin typeface="Arial" pitchFamily="34" charset="0"/>
+                <a:ea typeface="Arial" pitchFamily="34" charset="-122"/>
+                <a:cs typeface="Arial" pitchFamily="34" charset="-120"/>
               </a:rPr>
-              <a:t>في آخر الآية نقف عليها بالألف</a:t>
+              <a:t>At the end of the verse we stop with the alif</a:t>
             </a:r>
-            <a:endParaRPr lang="ar-SA" sz="2800" dirty="0"/>
+            <a:endParaRPr lang="en-US" sz="2600" dirty="0"/>
           </a:p>
         </p:txBody>
       </p:sp>
@@ -9221,7 +9221,7 @@
         </p:nvSpPr>
         <p:spPr>
           <a:xfrm>
-            <a:off x="365760" y="903097"/>
+            <a:off x="365760" y="870712"/>
             <a:ext cx="8412480" cy="530352"/>
           </a:xfrm>
           <a:prstGeom prst="rect">
@@ -9234,21 +9234,21 @@
           <a:bodyPr wrap="none" lIns="0" tIns="0" rIns="0" bIns="0" rtlCol="0" anchor="ctr"/>
           <a:lstStyle/>
           <a:p>
-            <a:pPr rtl="1" algn="ctr" indent="0" marL="0">
+            <a:pPr algn="ctr" indent="0" marL="0">
               <a:buNone/>
             </a:pPr>
             <a:r>
-              <a:rPr lang="ar-SA" altLang="en-US" sz="2200" dirty="0">
+              <a:rPr lang="en-US" sz="2500" b="1" dirty="0">
                 <a:solidFill>
                   <a:srgbClr val="FFFFFF"/>
                 </a:solidFill>
-                <a:latin typeface="Traditional Arabic" pitchFamily="34" charset="0"/>
-                <a:ea typeface="Traditional Arabic" pitchFamily="34" charset="-122"/>
-                <a:cs typeface="Traditional Arabic" pitchFamily="34" charset="-120"/>
+                <a:latin typeface="Arial" pitchFamily="34" charset="0"/>
+                <a:ea typeface="Arial" pitchFamily="34" charset="-122"/>
+                <a:cs typeface="Arial" pitchFamily="34" charset="-120"/>
               </a:rPr>
-              <a:t>الصفر المستطيل: تُقرأ عند الوقف فقط</a:t>
+              <a:t>Upright oval: read only when you stop</a:t>
             </a:r>
-            <a:endParaRPr lang="ar-SA" sz="2200" dirty="0"/>
+            <a:endParaRPr lang="en-US" sz="2500" dirty="0"/>
           </a:p>
         </p:txBody>
       </p:sp>
@@ -9393,7 +9393,7 @@
         <p:spPr>
           <a:xfrm>
             <a:off x="457200" y="1664208"/>
-            <a:ext cx="914400" cy="672084"/>
+            <a:ext cx="1325880" cy="672084"/>
           </a:xfrm>
           <a:prstGeom prst="roundRect">
             <a:avLst>
@@ -9419,8 +9419,8 @@
         </p:nvSpPr>
         <p:spPr>
           <a:xfrm>
-            <a:off x="457200" y="1669253"/>
-            <a:ext cx="914400" cy="672084"/>
+            <a:off x="457200" y="1647952"/>
+            <a:ext cx="1325880" cy="672084"/>
           </a:xfrm>
           <a:prstGeom prst="rect">
             <a:avLst/>
@@ -9432,21 +9432,21 @@
           <a:bodyPr wrap="none" lIns="0" tIns="0" rIns="0" bIns="0" rtlCol="0" anchor="ctr"/>
           <a:lstStyle/>
           <a:p>
-            <a:pPr rtl="1" algn="ctr" indent="0" marL="0">
+            <a:pPr algn="ctr" indent="0" marL="0">
               <a:buNone/>
             </a:pPr>
             <a:r>
-              <a:rPr lang="ar-SA" altLang="en-US" sz="3000" dirty="0">
+              <a:rPr lang="en-US" sz="1600" b="1" dirty="0">
                 <a:solidFill>
                   <a:srgbClr val="FFFFFF"/>
                 </a:solidFill>
-                <a:latin typeface="Traditional Arabic" pitchFamily="34" charset="0"/>
-                <a:ea typeface="Traditional Arabic" pitchFamily="34" charset="-122"/>
-                <a:cs typeface="Traditional Arabic" pitchFamily="34" charset="-120"/>
+                <a:latin typeface="Arial" pitchFamily="34" charset="0"/>
+                <a:ea typeface="Arial" pitchFamily="34" charset="-122"/>
+                <a:cs typeface="Arial" pitchFamily="34" charset="-120"/>
               </a:rPr>
-              <a:t>وصلاً</a:t>
+              <a:t>Connecting</a:t>
             </a:r>
-            <a:endParaRPr lang="ar-SA" sz="3000" dirty="0"/>
+            <a:endParaRPr lang="en-US" sz="1600" dirty="0"/>
           </a:p>
         </p:txBody>
       </p:sp>
@@ -9458,8 +9458,8 @@
         </p:nvSpPr>
         <p:spPr>
           <a:xfrm>
-            <a:off x="1417320" y="1537525"/>
-            <a:ext cx="2743200" cy="891540"/>
+            <a:off x="1828800" y="1537525"/>
+            <a:ext cx="2331720" cy="891540"/>
           </a:xfrm>
           <a:prstGeom prst="rect">
             <a:avLst/>
@@ -9525,7 +9525,7 @@
         <p:spPr>
           <a:xfrm>
             <a:off x="457200" y="2647188"/>
-            <a:ext cx="914400" cy="672084"/>
+            <a:ext cx="1325880" cy="672084"/>
           </a:xfrm>
           <a:prstGeom prst="roundRect">
             <a:avLst>
@@ -9551,8 +9551,8 @@
         </p:nvSpPr>
         <p:spPr>
           <a:xfrm>
-            <a:off x="457200" y="2671547"/>
-            <a:ext cx="914400" cy="672084"/>
+            <a:off x="457200" y="2625852"/>
+            <a:ext cx="1325880" cy="672084"/>
           </a:xfrm>
           <a:prstGeom prst="rect">
             <a:avLst/>
@@ -9564,21 +9564,21 @@
           <a:bodyPr wrap="none" lIns="0" tIns="0" rIns="0" bIns="0" rtlCol="0" anchor="ctr"/>
           <a:lstStyle/>
           <a:p>
-            <a:pPr rtl="1" algn="ctr" indent="0" marL="0">
+            <a:pPr algn="ctr" indent="0" marL="0">
               <a:buNone/>
             </a:pPr>
             <a:r>
-              <a:rPr lang="ar-SA" altLang="en-US" sz="2800" dirty="0">
+              <a:rPr lang="en-US" sz="2100" b="1" dirty="0">
                 <a:solidFill>
                   <a:srgbClr val="FFFFFF"/>
                 </a:solidFill>
-                <a:latin typeface="Traditional Arabic" pitchFamily="34" charset="0"/>
-                <a:ea typeface="Traditional Arabic" pitchFamily="34" charset="-122"/>
-                <a:cs typeface="Traditional Arabic" pitchFamily="34" charset="-120"/>
+                <a:latin typeface="Arial" pitchFamily="34" charset="0"/>
+                <a:ea typeface="Arial" pitchFamily="34" charset="-122"/>
+                <a:cs typeface="Arial" pitchFamily="34" charset="-120"/>
               </a:rPr>
-              <a:t>وقفاً</a:t>
+              <a:t>Stopping</a:t>
             </a:r>
-            <a:endParaRPr lang="ar-SA" sz="2800" dirty="0"/>
+            <a:endParaRPr lang="en-US" sz="2100" dirty="0"/>
           </a:p>
         </p:txBody>
       </p:sp>
@@ -9590,8 +9590,8 @@
         </p:nvSpPr>
         <p:spPr>
           <a:xfrm>
-            <a:off x="1417320" y="2521268"/>
-            <a:ext cx="2743200" cy="891540"/>
+            <a:off x="1828800" y="2521268"/>
+            <a:ext cx="2331720" cy="891540"/>
           </a:xfrm>
           <a:prstGeom prst="rect">
             <a:avLst/>
@@ -9670,7 +9670,7 @@
         </p:nvSpPr>
         <p:spPr>
           <a:xfrm>
-            <a:off x="365760" y="3573018"/>
+            <a:off x="365760" y="3572764"/>
             <a:ext cx="8412480" cy="685800"/>
           </a:xfrm>
           <a:prstGeom prst="rect">
@@ -9683,21 +9683,21 @@
           <a:bodyPr wrap="none" lIns="0" tIns="0" rIns="0" bIns="0" rtlCol="0" anchor="ctr"/>
           <a:lstStyle/>
           <a:p>
-            <a:pPr rtl="1" algn="ctr" indent="0" marL="0">
+            <a:pPr algn="ctr" indent="0" marL="0">
               <a:buNone/>
             </a:pPr>
             <a:r>
-              <a:rPr lang="ar-SA" altLang="en-US" sz="3000" dirty="0">
+              <a:rPr lang="en-US" sz="2600" b="1" dirty="0">
                 <a:solidFill>
                   <a:srgbClr val="FFFFFF"/>
                 </a:solidFill>
-                <a:latin typeface="Traditional Arabic" pitchFamily="34" charset="0"/>
-                <a:ea typeface="Traditional Arabic" pitchFamily="34" charset="-122"/>
-                <a:cs typeface="Traditional Arabic" pitchFamily="34" charset="-120"/>
+                <a:latin typeface="Arial" pitchFamily="34" charset="0"/>
+                <a:ea typeface="Arial" pitchFamily="34" charset="-122"/>
+                <a:cs typeface="Arial" pitchFamily="34" charset="-120"/>
               </a:rPr>
-              <a:t>ومثلها «ٱلرَّسُولَا۠»</a:t>
+              <a:t>Also ar-rasoolaa</a:t>
             </a:r>
-            <a:endParaRPr lang="ar-SA" sz="3000" dirty="0"/>
+            <a:endParaRPr lang="en-US" sz="2600" dirty="0"/>
           </a:p>
         </p:txBody>
       </p:sp>
@@ -10537,7 +10537,7 @@
         </p:nvSpPr>
         <p:spPr>
           <a:xfrm>
-            <a:off x="365760" y="843242"/>
+            <a:off x="365760" y="870712"/>
             <a:ext cx="8412480" cy="530352"/>
           </a:xfrm>
           <a:prstGeom prst="rect">
@@ -10550,21 +10550,21 @@
           <a:bodyPr wrap="none" lIns="0" tIns="0" rIns="0" bIns="0" rtlCol="0" anchor="ctr"/>
           <a:lstStyle/>
           <a:p>
-            <a:pPr rtl="1" algn="ctr" indent="0" marL="0">
+            <a:pPr algn="ctr" indent="0" marL="0">
               <a:buNone/>
             </a:pPr>
             <a:r>
-              <a:rPr lang="ar-SA" altLang="en-US" sz="2300" dirty="0">
+              <a:rPr lang="en-US" sz="2500" b="1" dirty="0">
                 <a:solidFill>
                   <a:srgbClr val="FFFFFF"/>
                 </a:solidFill>
-                <a:latin typeface="Traditional Arabic" pitchFamily="34" charset="0"/>
-                <a:ea typeface="Traditional Arabic" pitchFamily="34" charset="-122"/>
-                <a:cs typeface="Traditional Arabic" pitchFamily="34" charset="-120"/>
+                <a:latin typeface="Arial" pitchFamily="34" charset="0"/>
+                <a:ea typeface="Arial" pitchFamily="34" charset="-122"/>
+                <a:cs typeface="Arial" pitchFamily="34" charset="-120"/>
               </a:rPr>
-              <a:t>بلا علامة: تسقط في الوصل</a:t>
+              <a:t>No sign: dropped when connecting</a:t>
             </a:r>
-            <a:endParaRPr lang="ar-SA" sz="2300" dirty="0"/>
+            <a:endParaRPr lang="en-US" sz="2500" dirty="0"/>
           </a:p>
         </p:txBody>
       </p:sp>
@@ -10827,7 +10827,7 @@
         </p:nvSpPr>
         <p:spPr>
           <a:xfrm>
-            <a:off x="365760" y="3545243"/>
+            <a:off x="365760" y="3540760"/>
             <a:ext cx="8412480" cy="685800"/>
           </a:xfrm>
           <a:prstGeom prst="rect">
@@ -10840,21 +10840,21 @@
           <a:bodyPr wrap="none" lIns="0" tIns="0" rIns="0" bIns="0" rtlCol="0" anchor="ctr"/>
           <a:lstStyle/>
           <a:p>
-            <a:pPr rtl="1" algn="ctr" indent="0" marL="0">
+            <a:pPr algn="ctr" indent="0" marL="0">
               <a:buNone/>
             </a:pPr>
             <a:r>
-              <a:rPr lang="ar-SA" altLang="en-US" sz="2700" dirty="0">
+              <a:rPr lang="en-US" sz="2500" b="1" dirty="0">
                 <a:solidFill>
                   <a:srgbClr val="FFFFFF"/>
                 </a:solidFill>
-                <a:latin typeface="Traditional Arabic" pitchFamily="34" charset="0"/>
-                <a:ea typeface="Traditional Arabic" pitchFamily="34" charset="-122"/>
-                <a:cs typeface="Traditional Arabic" pitchFamily="34" charset="-120"/>
+                <a:latin typeface="Arial" pitchFamily="34" charset="0"/>
+                <a:ea typeface="Arial" pitchFamily="34" charset="-122"/>
+                <a:cs typeface="Arial" pitchFamily="34" charset="-120"/>
               </a:rPr>
-              <a:t>همزة الوصل لا تُقرأ في وسط الكلام</a:t>
+              <a:t>Hamzat al-wasl is not read in the middle of speech</a:t>
             </a:r>
-            <a:endParaRPr lang="ar-SA" sz="2700" dirty="0"/>
+            <a:endParaRPr lang="en-US" sz="2500" dirty="0"/>
           </a:p>
         </p:txBody>
       </p:sp>
@@ -11485,7 +11485,7 @@
         </p:nvSpPr>
         <p:spPr>
           <a:xfrm>
-            <a:off x="365760" y="843242"/>
+            <a:off x="365760" y="870712"/>
             <a:ext cx="8412480" cy="530352"/>
           </a:xfrm>
           <a:prstGeom prst="rect">
@@ -11498,21 +11498,21 @@
           <a:bodyPr wrap="none" lIns="0" tIns="0" rIns="0" bIns="0" rtlCol="0" anchor="ctr"/>
           <a:lstStyle/>
           <a:p>
-            <a:pPr rtl="1" algn="ctr" indent="0" marL="0">
+            <a:pPr algn="ctr" indent="0" marL="0">
               <a:buNone/>
             </a:pPr>
             <a:r>
-              <a:rPr lang="ar-SA" altLang="en-US" sz="2300" dirty="0">
+              <a:rPr lang="en-US" sz="2500" b="1" dirty="0">
                 <a:solidFill>
                   <a:srgbClr val="FFFFFF"/>
                 </a:solidFill>
-                <a:latin typeface="Traditional Arabic" pitchFamily="34" charset="0"/>
-                <a:ea typeface="Traditional Arabic" pitchFamily="34" charset="-122"/>
-                <a:cs typeface="Traditional Arabic" pitchFamily="34" charset="-120"/>
+                <a:latin typeface="Arial" pitchFamily="34" charset="0"/>
+                <a:ea typeface="Arial" pitchFamily="34" charset="-122"/>
+                <a:cs typeface="Arial" pitchFamily="34" charset="-120"/>
               </a:rPr>
-              <a:t>بلا علامة: تسقط في الوصل</a:t>
+              <a:t>No sign: dropped when connecting</a:t>
             </a:r>
-            <a:endParaRPr lang="ar-SA" sz="2300" dirty="0"/>
+            <a:endParaRPr lang="en-US" sz="2500" dirty="0"/>
           </a:p>
         </p:txBody>
       </p:sp>
@@ -11775,7 +11775,7 @@
         </p:nvSpPr>
         <p:spPr>
           <a:xfrm>
-            <a:off x="365760" y="3548380"/>
+            <a:off x="365760" y="3549650"/>
             <a:ext cx="8412480" cy="685800"/>
           </a:xfrm>
           <a:prstGeom prst="rect">
@@ -11788,21 +11788,21 @@
           <a:bodyPr wrap="none" lIns="0" tIns="0" rIns="0" bIns="0" rtlCol="0" anchor="ctr"/>
           <a:lstStyle/>
           <a:p>
-            <a:pPr rtl="1" algn="ctr" indent="0" marL="0">
+            <a:pPr algn="ctr" indent="0" marL="0">
               <a:buNone/>
             </a:pPr>
             <a:r>
-              <a:rPr lang="ar-SA" altLang="en-US" sz="2800" dirty="0">
+              <a:rPr lang="en-US" sz="2600" b="1" dirty="0">
                 <a:solidFill>
                   <a:srgbClr val="FFFFFF"/>
                 </a:solidFill>
-                <a:latin typeface="Traditional Arabic" pitchFamily="34" charset="0"/>
-                <a:ea typeface="Traditional Arabic" pitchFamily="34" charset="-122"/>
-                <a:cs typeface="Traditional Arabic" pitchFamily="34" charset="-120"/>
+                <a:latin typeface="Arial" pitchFamily="34" charset="0"/>
+                <a:ea typeface="Arial" pitchFamily="34" charset="-122"/>
+                <a:cs typeface="Arial" pitchFamily="34" charset="-120"/>
               </a:rPr>
-              <a:t>اللام الشمسية تُكتب ولا تُقرأ</a:t>
+              <a:t>The sun lam is written, not read</a:t>
             </a:r>
-            <a:endParaRPr lang="ar-SA" sz="2800" dirty="0"/>
+            <a:endParaRPr lang="en-US" sz="2600" dirty="0"/>
           </a:p>
         </p:txBody>
       </p:sp>
@@ -12393,7 +12393,7 @@
         </p:nvSpPr>
         <p:spPr>
           <a:xfrm>
-            <a:off x="365760" y="843242"/>
+            <a:off x="365760" y="870712"/>
             <a:ext cx="8412480" cy="530352"/>
           </a:xfrm>
           <a:prstGeom prst="rect">
@@ -12406,21 +12406,21 @@
           <a:bodyPr wrap="none" lIns="0" tIns="0" rIns="0" bIns="0" rtlCol="0" anchor="ctr"/>
           <a:lstStyle/>
           <a:p>
-            <a:pPr rtl="1" algn="ctr" indent="0" marL="0">
+            <a:pPr algn="ctr" indent="0" marL="0">
               <a:buNone/>
             </a:pPr>
             <a:r>
-              <a:rPr lang="ar-SA" altLang="en-US" sz="2300" dirty="0">
+              <a:rPr lang="en-US" sz="2500" b="1" dirty="0">
                 <a:solidFill>
                   <a:srgbClr val="FFFFFF"/>
                 </a:solidFill>
-                <a:latin typeface="Traditional Arabic" pitchFamily="34" charset="0"/>
-                <a:ea typeface="Traditional Arabic" pitchFamily="34" charset="-122"/>
-                <a:cs typeface="Traditional Arabic" pitchFamily="34" charset="-120"/>
+                <a:latin typeface="Arial" pitchFamily="34" charset="0"/>
+                <a:ea typeface="Arial" pitchFamily="34" charset="-122"/>
+                <a:cs typeface="Arial" pitchFamily="34" charset="-120"/>
               </a:rPr>
-              <a:t>بلا علامة: تسقط في الوصل</a:t>
+              <a:t>No sign: dropped when connecting</a:t>
             </a:r>
-            <a:endParaRPr lang="ar-SA" sz="2300" dirty="0"/>
+            <a:endParaRPr lang="en-US" sz="2500" dirty="0"/>
           </a:p>
         </p:txBody>
       </p:sp>
@@ -12683,7 +12683,7 @@
         </p:nvSpPr>
         <p:spPr>
           <a:xfrm>
-            <a:off x="365760" y="3534221"/>
+            <a:off x="365760" y="3552825"/>
             <a:ext cx="8412480" cy="685800"/>
           </a:xfrm>
           <a:prstGeom prst="rect">
@@ -12696,21 +12696,21 @@
           <a:bodyPr wrap="none" lIns="0" tIns="0" rIns="0" bIns="0" rtlCol="0" anchor="ctr"/>
           <a:lstStyle/>
           <a:p>
-            <a:pPr rtl="1" algn="ctr" indent="0" marL="0">
+            <a:pPr algn="ctr" indent="0" marL="0">
               <a:buNone/>
             </a:pPr>
             <a:r>
-              <a:rPr lang="ar-SA" altLang="en-US" sz="3000" dirty="0">
+              <a:rPr lang="en-US" sz="2100" b="1" dirty="0">
                 <a:solidFill>
                   <a:srgbClr val="FFFFFF"/>
                 </a:solidFill>
-                <a:latin typeface="Traditional Arabic" pitchFamily="34" charset="0"/>
-                <a:ea typeface="Traditional Arabic" pitchFamily="34" charset="-122"/>
-                <a:cs typeface="Traditional Arabic" pitchFamily="34" charset="-120"/>
+                <a:latin typeface="Arial" pitchFamily="34" charset="0"/>
+                <a:ea typeface="Arial" pitchFamily="34" charset="-122"/>
+                <a:cs typeface="Arial" pitchFamily="34" charset="-120"/>
               </a:rPr>
-              <a:t>حرف المد قبل حرف ساكن: يُكتب ولا يُمد</a:t>
+              <a:t>A madd letter before a silent letter is written, not stretched</a:t>
             </a:r>
-            <a:endParaRPr lang="ar-SA" sz="3000" dirty="0"/>
+            <a:endParaRPr lang="en-US" sz="2100" dirty="0"/>
           </a:p>
         </p:txBody>
       </p:sp>
@@ -13491,7 +13491,7 @@
         </p:nvSpPr>
         <p:spPr>
           <a:xfrm>
-            <a:off x="365760" y="843242"/>
+            <a:off x="365760" y="870712"/>
             <a:ext cx="8412480" cy="530352"/>
           </a:xfrm>
           <a:prstGeom prst="rect">
@@ -13504,21 +13504,21 @@
           <a:bodyPr wrap="none" lIns="0" tIns="0" rIns="0" bIns="0" rtlCol="0" anchor="ctr"/>
           <a:lstStyle/>
           <a:p>
-            <a:pPr rtl="1" algn="ctr" indent="0" marL="0">
+            <a:pPr algn="ctr" indent="0" marL="0">
               <a:buNone/>
             </a:pPr>
             <a:r>
-              <a:rPr lang="ar-SA" altLang="en-US" sz="2300" dirty="0">
+              <a:rPr lang="en-US" sz="2500" b="1" dirty="0">
                 <a:solidFill>
                   <a:srgbClr val="FFFFFF"/>
                 </a:solidFill>
-                <a:latin typeface="Traditional Arabic" pitchFamily="34" charset="0"/>
-                <a:ea typeface="Traditional Arabic" pitchFamily="34" charset="-122"/>
-                <a:cs typeface="Traditional Arabic" pitchFamily="34" charset="-120"/>
+                <a:latin typeface="Arial" pitchFamily="34" charset="0"/>
+                <a:ea typeface="Arial" pitchFamily="34" charset="-122"/>
+                <a:cs typeface="Arial" pitchFamily="34" charset="-120"/>
               </a:rPr>
-              <a:t>بلا علامة: تسقط في الوصل</a:t>
+              <a:t>No sign: dropped when connecting</a:t>
             </a:r>
-            <a:endParaRPr lang="ar-SA" sz="2300" dirty="0"/>
+            <a:endParaRPr lang="en-US" sz="2500" dirty="0"/>
           </a:p>
         </p:txBody>
       </p:sp>
@@ -13781,7 +13781,7 @@
         </p:nvSpPr>
         <p:spPr>
           <a:xfrm>
-            <a:off x="365760" y="3591389"/>
+            <a:off x="365760" y="3543808"/>
             <a:ext cx="8412480" cy="685800"/>
           </a:xfrm>
           <a:prstGeom prst="rect">
@@ -13794,21 +13794,21 @@
           <a:bodyPr wrap="none" lIns="0" tIns="0" rIns="0" bIns="0" rtlCol="0" anchor="ctr"/>
           <a:lstStyle/>
           <a:p>
-            <a:pPr rtl="1" algn="ctr" indent="0" marL="0">
+            <a:pPr algn="ctr" indent="0" marL="0">
               <a:buNone/>
             </a:pPr>
             <a:r>
-              <a:rPr lang="ar-SA" altLang="en-US" sz="2900" dirty="0">
+              <a:rPr lang="en-US" sz="2200" b="1" dirty="0">
                 <a:solidFill>
                   <a:srgbClr val="FFFFFF"/>
                 </a:solidFill>
-                <a:latin typeface="Traditional Arabic" pitchFamily="34" charset="0"/>
-                <a:ea typeface="Traditional Arabic" pitchFamily="34" charset="-122"/>
-                <a:cs typeface="Traditional Arabic" pitchFamily="34" charset="-120"/>
+                <a:latin typeface="Arial" pitchFamily="34" charset="0"/>
+                <a:ea typeface="Arial" pitchFamily="34" charset="-122"/>
+                <a:cs typeface="Arial" pitchFamily="34" charset="-120"/>
               </a:rPr>
-              <a:t>الواو تسقط للساكن بعدها، والألف لا تُقرأ أبداً</a:t>
+              <a:t>The waw drops before the silent lam; the alif is never read</a:t>
             </a:r>
-            <a:endParaRPr lang="ar-SA" sz="2900" dirty="0"/>
+            <a:endParaRPr lang="en-US" sz="2200" dirty="0"/>
           </a:p>
         </p:txBody>
       </p:sp>
@@ -14516,7 +14516,7 @@
         </p:nvSpPr>
         <p:spPr>
           <a:xfrm>
-            <a:off x="365760" y="883412"/>
+            <a:off x="365760" y="902716"/>
             <a:ext cx="8412480" cy="530352"/>
           </a:xfrm>
           <a:prstGeom prst="rect">
@@ -14529,21 +14529,21 @@
           <a:bodyPr wrap="none" lIns="0" tIns="0" rIns="0" bIns="0" rtlCol="0" anchor="ctr"/>
           <a:lstStyle/>
           <a:p>
-            <a:pPr rtl="1" algn="ctr" indent="0" marL="0">
+            <a:pPr algn="ctr" indent="0" marL="0">
               <a:buNone/>
             </a:pPr>
             <a:r>
-              <a:rPr lang="ar-SA" altLang="en-US" sz="2000" dirty="0">
+              <a:rPr lang="en-US" sz="2600" b="1" dirty="0">
                 <a:solidFill>
                   <a:srgbClr val="FFFFFF"/>
                 </a:solidFill>
-                <a:latin typeface="Traditional Arabic" pitchFamily="34" charset="0"/>
-                <a:ea typeface="Traditional Arabic" pitchFamily="34" charset="-122"/>
-                <a:cs typeface="Traditional Arabic" pitchFamily="34" charset="-120"/>
+                <a:latin typeface="Arial" pitchFamily="34" charset="0"/>
+                <a:ea typeface="Arial" pitchFamily="34" charset="-122"/>
+                <a:cs typeface="Arial" pitchFamily="34" charset="-120"/>
               </a:rPr>
-              <a:t>ألف تنوين الفتح</a:t>
+              <a:t>The alif after fathatan</a:t>
             </a:r>
-            <a:endParaRPr lang="ar-SA" sz="2000" dirty="0"/>
+            <a:endParaRPr lang="en-US" sz="2600" dirty="0"/>
           </a:p>
         </p:txBody>
       </p:sp>
@@ -14688,7 +14688,7 @@
         <p:spPr>
           <a:xfrm>
             <a:off x="457200" y="1664208"/>
-            <a:ext cx="914400" cy="672084"/>
+            <a:ext cx="1325880" cy="672084"/>
           </a:xfrm>
           <a:prstGeom prst="roundRect">
             <a:avLst>
@@ -14714,8 +14714,8 @@
         </p:nvSpPr>
         <p:spPr>
           <a:xfrm>
-            <a:off x="457200" y="1669253"/>
-            <a:ext cx="914400" cy="672084"/>
+            <a:off x="457200" y="1647952"/>
+            <a:ext cx="1325880" cy="672084"/>
           </a:xfrm>
           <a:prstGeom prst="rect">
             <a:avLst/>
@@ -14727,21 +14727,21 @@
           <a:bodyPr wrap="none" lIns="0" tIns="0" rIns="0" bIns="0" rtlCol="0" anchor="ctr"/>
           <a:lstStyle/>
           <a:p>
-            <a:pPr rtl="1" algn="ctr" indent="0" marL="0">
+            <a:pPr algn="ctr" indent="0" marL="0">
               <a:buNone/>
             </a:pPr>
             <a:r>
-              <a:rPr lang="ar-SA" altLang="en-US" sz="3000" dirty="0">
+              <a:rPr lang="en-US" sz="1600" b="1" dirty="0">
                 <a:solidFill>
                   <a:srgbClr val="FFFFFF"/>
                 </a:solidFill>
-                <a:latin typeface="Traditional Arabic" pitchFamily="34" charset="0"/>
-                <a:ea typeface="Traditional Arabic" pitchFamily="34" charset="-122"/>
-                <a:cs typeface="Traditional Arabic" pitchFamily="34" charset="-120"/>
+                <a:latin typeface="Arial" pitchFamily="34" charset="0"/>
+                <a:ea typeface="Arial" pitchFamily="34" charset="-122"/>
+                <a:cs typeface="Arial" pitchFamily="34" charset="-120"/>
               </a:rPr>
-              <a:t>وصلاً</a:t>
+              <a:t>Connecting</a:t>
             </a:r>
-            <a:endParaRPr lang="ar-SA" sz="3000" dirty="0"/>
+            <a:endParaRPr lang="en-US" sz="1600" dirty="0"/>
           </a:p>
         </p:txBody>
       </p:sp>
@@ -14753,8 +14753,8 @@
         </p:nvSpPr>
         <p:spPr>
           <a:xfrm>
-            <a:off x="1417320" y="1533677"/>
-            <a:ext cx="2743200" cy="891540"/>
+            <a:off x="1828800" y="1533677"/>
+            <a:ext cx="2331720" cy="891540"/>
           </a:xfrm>
           <a:prstGeom prst="rect">
             <a:avLst/>
@@ -14820,7 +14820,7 @@
         <p:spPr>
           <a:xfrm>
             <a:off x="457200" y="2647188"/>
-            <a:ext cx="914400" cy="672084"/>
+            <a:ext cx="1325880" cy="672084"/>
           </a:xfrm>
           <a:prstGeom prst="roundRect">
             <a:avLst>
@@ -14846,8 +14846,8 @@
         </p:nvSpPr>
         <p:spPr>
           <a:xfrm>
-            <a:off x="457200" y="2671547"/>
-            <a:ext cx="914400" cy="672084"/>
+            <a:off x="457200" y="2625852"/>
+            <a:ext cx="1325880" cy="672084"/>
           </a:xfrm>
           <a:prstGeom prst="rect">
             <a:avLst/>
@@ -14859,21 +14859,21 @@
           <a:bodyPr wrap="none" lIns="0" tIns="0" rIns="0" bIns="0" rtlCol="0" anchor="ctr"/>
           <a:lstStyle/>
           <a:p>
-            <a:pPr rtl="1" algn="ctr" indent="0" marL="0">
+            <a:pPr algn="ctr" indent="0" marL="0">
               <a:buNone/>
             </a:pPr>
             <a:r>
-              <a:rPr lang="ar-SA" altLang="en-US" sz="2800" dirty="0">
+              <a:rPr lang="en-US" sz="2100" b="1" dirty="0">
                 <a:solidFill>
                   <a:srgbClr val="FFFFFF"/>
                 </a:solidFill>
-                <a:latin typeface="Traditional Arabic" pitchFamily="34" charset="0"/>
-                <a:ea typeface="Traditional Arabic" pitchFamily="34" charset="-122"/>
-                <a:cs typeface="Traditional Arabic" pitchFamily="34" charset="-120"/>
+                <a:latin typeface="Arial" pitchFamily="34" charset="0"/>
+                <a:ea typeface="Arial" pitchFamily="34" charset="-122"/>
+                <a:cs typeface="Arial" pitchFamily="34" charset="-120"/>
               </a:rPr>
-              <a:t>وقفاً</a:t>
+              <a:t>Stopping</a:t>
             </a:r>
-            <a:endParaRPr lang="ar-SA" sz="2800" dirty="0"/>
+            <a:endParaRPr lang="en-US" sz="2100" dirty="0"/>
           </a:p>
         </p:txBody>
       </p:sp>
@@ -14885,8 +14885,8 @@
         </p:nvSpPr>
         <p:spPr>
           <a:xfrm>
-            <a:off x="1417320" y="2503170"/>
-            <a:ext cx="2743200" cy="891540"/>
+            <a:off x="1828800" y="2503170"/>
+            <a:ext cx="2331720" cy="891540"/>
           </a:xfrm>
           <a:prstGeom prst="rect">
             <a:avLst/>
@@ -14965,7 +14965,7 @@
         </p:nvSpPr>
         <p:spPr>
           <a:xfrm>
-            <a:off x="365760" y="3545243"/>
+            <a:off x="365760" y="3543808"/>
             <a:ext cx="8412480" cy="685800"/>
           </a:xfrm>
           <a:prstGeom prst="rect">
@@ -14978,21 +14978,21 @@
           <a:bodyPr wrap="none" lIns="0" tIns="0" rIns="0" bIns="0" rtlCol="0" anchor="ctr"/>
           <a:lstStyle/>
           <a:p>
-            <a:pPr rtl="1" algn="ctr" indent="0" marL="0">
+            <a:pPr algn="ctr" indent="0" marL="0">
               <a:buNone/>
             </a:pPr>
             <a:r>
-              <a:rPr lang="ar-SA" altLang="en-US" sz="2700" dirty="0">
+              <a:rPr lang="en-US" sz="2200" b="1" dirty="0">
                 <a:solidFill>
                   <a:srgbClr val="FFFFFF"/>
                 </a:solidFill>
-                <a:latin typeface="Traditional Arabic" pitchFamily="34" charset="0"/>
-                <a:ea typeface="Traditional Arabic" pitchFamily="34" charset="-122"/>
-                <a:cs typeface="Traditional Arabic" pitchFamily="34" charset="-120"/>
+                <a:latin typeface="Arial" pitchFamily="34" charset="0"/>
+                <a:ea typeface="Arial" pitchFamily="34" charset="-122"/>
+                <a:cs typeface="Arial" pitchFamily="34" charset="-120"/>
               </a:rPr>
-              <a:t>في الوصل لا تُقرأ الألف، وعند الوقف نقرؤها ألف مد</a:t>
+              <a:t>Connecting: the alif is silent.  Stopping: read it as a long aa</a:t>
             </a:r>
-            <a:endParaRPr lang="ar-SA" sz="2700" dirty="0"/>
+            <a:endParaRPr lang="en-US" sz="2200" dirty="0"/>
           </a:p>
         </p:txBody>
       </p:sp>
@@ -15807,7 +15807,7 @@
         </p:nvSpPr>
         <p:spPr>
           <a:xfrm>
-            <a:off x="365760" y="914381"/>
+            <a:off x="365760" y="902716"/>
             <a:ext cx="8412480" cy="530352"/>
           </a:xfrm>
           <a:prstGeom prst="rect">
@@ -15820,21 +15820,21 @@
           <a:bodyPr wrap="none" lIns="0" tIns="0" rIns="0" bIns="0" rtlCol="0" anchor="ctr"/>
           <a:lstStyle/>
           <a:p>
-            <a:pPr rtl="1" algn="ctr" indent="0" marL="0">
+            <a:pPr algn="ctr" indent="0" marL="0">
               <a:buNone/>
             </a:pPr>
             <a:r>
-              <a:rPr lang="ar-SA" altLang="en-US" sz="2100" dirty="0">
+              <a:rPr lang="en-US" sz="2600" b="1" dirty="0">
                 <a:solidFill>
                   <a:srgbClr val="FFFFFF"/>
                 </a:solidFill>
-                <a:latin typeface="Traditional Arabic" pitchFamily="34" charset="0"/>
-                <a:ea typeface="Traditional Arabic" pitchFamily="34" charset="-122"/>
-                <a:cs typeface="Traditional Arabic" pitchFamily="34" charset="-120"/>
+                <a:latin typeface="Arial" pitchFamily="34" charset="0"/>
+                <a:ea typeface="Arial" pitchFamily="34" charset="-122"/>
+                <a:cs typeface="Arial" pitchFamily="34" charset="-120"/>
               </a:rPr>
-              <a:t>الدائرة الصغيرة: لا تُقرأ أبداً</a:t>
+              <a:t>Small circle: never read</a:t>
             </a:r>
-            <a:endParaRPr lang="ar-SA" sz="2100" dirty="0"/>
+            <a:endParaRPr lang="en-US" sz="2600" dirty="0"/>
           </a:p>
         </p:txBody>
       </p:sp>
@@ -16083,7 +16083,7 @@
         </p:nvSpPr>
         <p:spPr>
           <a:xfrm>
-            <a:off x="365760" y="3575685"/>
+            <a:off x="365760" y="3539744"/>
             <a:ext cx="8412480" cy="685800"/>
           </a:xfrm>
           <a:prstGeom prst="rect">
@@ -16096,21 +16096,21 @@
           <a:bodyPr wrap="none" lIns="0" tIns="0" rIns="0" bIns="0" rtlCol="0" anchor="ctr"/>
           <a:lstStyle/>
           <a:p>
-            <a:pPr rtl="1" algn="ctr" indent="0" marL="0">
+            <a:pPr algn="ctr" indent="0" marL="0">
               <a:buNone/>
             </a:pPr>
             <a:r>
-              <a:rPr lang="ar-SA" altLang="en-US" sz="3000" dirty="0">
+              <a:rPr lang="en-US" sz="2600" b="1" dirty="0">
                 <a:solidFill>
                   <a:srgbClr val="FFFFFF"/>
                 </a:solidFill>
-                <a:latin typeface="Traditional Arabic" pitchFamily="34" charset="0"/>
-                <a:ea typeface="Traditional Arabic" pitchFamily="34" charset="-122"/>
-                <a:cs typeface="Traditional Arabic" pitchFamily="34" charset="-120"/>
+                <a:latin typeface="Arial" pitchFamily="34" charset="0"/>
+                <a:ea typeface="Arial" pitchFamily="34" charset="-122"/>
+                <a:cs typeface="Arial" pitchFamily="34" charset="-120"/>
               </a:rPr>
-              <a:t>ألف واو الجماعة: نكتبها ولا نقرؤها</a:t>
+              <a:t>The alif after the plural waw is written, not read</a:t>
             </a:r>
-            <a:endParaRPr lang="ar-SA" sz="3000" dirty="0"/>
+            <a:endParaRPr lang="en-US" sz="2600" dirty="0"/>
           </a:p>
         </p:txBody>
       </p:sp>
@@ -16691,7 +16691,7 @@
         </p:nvSpPr>
         <p:spPr>
           <a:xfrm>
-            <a:off x="365760" y="903097"/>
+            <a:off x="365760" y="879602"/>
             <a:ext cx="8412480" cy="530352"/>
           </a:xfrm>
           <a:prstGeom prst="rect">
@@ -16704,21 +16704,21 @@
           <a:bodyPr wrap="none" lIns="0" tIns="0" rIns="0" bIns="0" rtlCol="0" anchor="ctr"/>
           <a:lstStyle/>
           <a:p>
-            <a:pPr rtl="1" algn="ctr" indent="0" marL="0">
+            <a:pPr algn="ctr" indent="0" marL="0">
               <a:buNone/>
             </a:pPr>
             <a:r>
-              <a:rPr lang="ar-SA" altLang="en-US" sz="2200" dirty="0">
+              <a:rPr lang="en-US" sz="2600" b="1" dirty="0">
                 <a:solidFill>
                   <a:srgbClr val="FFFFFF"/>
                 </a:solidFill>
-                <a:latin typeface="Traditional Arabic" pitchFamily="34" charset="0"/>
-                <a:ea typeface="Traditional Arabic" pitchFamily="34" charset="-122"/>
-                <a:cs typeface="Traditional Arabic" pitchFamily="34" charset="-120"/>
+                <a:latin typeface="Arial" pitchFamily="34" charset="0"/>
+                <a:ea typeface="Arial" pitchFamily="34" charset="-122"/>
+                <a:cs typeface="Arial" pitchFamily="34" charset="-120"/>
               </a:rPr>
-              <a:t>يُكتب حرف ويُقرأ غيره</a:t>
+              <a:t>Written as one letter, read as another</a:t>
             </a:r>
-            <a:endParaRPr lang="ar-SA" sz="2200" dirty="0"/>
+            <a:endParaRPr lang="en-US" sz="2600" dirty="0"/>
           </a:p>
         </p:txBody>
       </p:sp>
@@ -17009,7 +17009,7 @@
         </p:nvSpPr>
         <p:spPr>
           <a:xfrm>
-            <a:off x="365760" y="3575685"/>
+            <a:off x="365760" y="3542792"/>
             <a:ext cx="8412480" cy="685800"/>
           </a:xfrm>
           <a:prstGeom prst="rect">
@@ -17022,21 +17022,21 @@
           <a:bodyPr wrap="none" lIns="0" tIns="0" rIns="0" bIns="0" rtlCol="0" anchor="ctr"/>
           <a:lstStyle/>
           <a:p>
-            <a:pPr rtl="1" algn="ctr" indent="0" marL="0">
+            <a:pPr algn="ctr" indent="0" marL="0">
               <a:buNone/>
             </a:pPr>
             <a:r>
-              <a:rPr lang="ar-SA" altLang="en-US" sz="3000" dirty="0">
+              <a:rPr lang="en-US" sz="2300" b="1" dirty="0">
                 <a:solidFill>
                   <a:srgbClr val="FFFFFF"/>
                 </a:solidFill>
-                <a:latin typeface="Traditional Arabic" pitchFamily="34" charset="0"/>
-                <a:ea typeface="Traditional Arabic" pitchFamily="34" charset="-122"/>
-                <a:cs typeface="Traditional Arabic" pitchFamily="34" charset="-120"/>
+                <a:latin typeface="Arial" pitchFamily="34" charset="0"/>
+                <a:ea typeface="Arial" pitchFamily="34" charset="-122"/>
+                <a:cs typeface="Arial" pitchFamily="34" charset="-120"/>
               </a:rPr>
-              <a:t>الواو لا تُقرأ: نقرأ الألف الصغيرة فوقها</a:t>
+              <a:t>The waw is not read: we read the small alif on top of it</a:t>
             </a:r>
-            <a:endParaRPr lang="ar-SA" sz="3000" dirty="0"/>
+            <a:endParaRPr lang="en-US" sz="2300" dirty="0"/>
           </a:p>
         </p:txBody>
       </p:sp>
@@ -17642,7 +17642,7 @@
         </p:nvSpPr>
         <p:spPr>
           <a:xfrm>
-            <a:off x="365760" y="914381"/>
+            <a:off x="365760" y="902716"/>
             <a:ext cx="8412480" cy="530352"/>
           </a:xfrm>
           <a:prstGeom prst="rect">
@@ -17655,21 +17655,21 @@
           <a:bodyPr wrap="none" lIns="0" tIns="0" rIns="0" bIns="0" rtlCol="0" anchor="ctr"/>
           <a:lstStyle/>
           <a:p>
-            <a:pPr rtl="1" algn="ctr" indent="0" marL="0">
+            <a:pPr algn="ctr" indent="0" marL="0">
               <a:buNone/>
             </a:pPr>
             <a:r>
-              <a:rPr lang="ar-SA" altLang="en-US" sz="2100" dirty="0">
+              <a:rPr lang="en-US" sz="2600" b="1" dirty="0">
                 <a:solidFill>
                   <a:srgbClr val="FFFFFF"/>
                 </a:solidFill>
-                <a:latin typeface="Traditional Arabic" pitchFamily="34" charset="0"/>
-                <a:ea typeface="Traditional Arabic" pitchFamily="34" charset="-122"/>
-                <a:cs typeface="Traditional Arabic" pitchFamily="34" charset="-120"/>
+                <a:latin typeface="Arial" pitchFamily="34" charset="0"/>
+                <a:ea typeface="Arial" pitchFamily="34" charset="-122"/>
+                <a:cs typeface="Arial" pitchFamily="34" charset="-120"/>
               </a:rPr>
-              <a:t>الدائرة الصغيرة: لا تُقرأ أبداً</a:t>
+              <a:t>Small circle: never read</a:t>
             </a:r>
-            <a:endParaRPr lang="ar-SA" sz="2100" dirty="0"/>
+            <a:endParaRPr lang="en-US" sz="2600" dirty="0"/>
           </a:p>
         </p:txBody>
       </p:sp>
@@ -17918,7 +17918,7 @@
         </p:nvSpPr>
         <p:spPr>
           <a:xfrm>
-            <a:off x="365760" y="3575685"/>
+            <a:off x="365760" y="3539744"/>
             <a:ext cx="8412480" cy="685800"/>
           </a:xfrm>
           <a:prstGeom prst="rect">
@@ -17931,21 +17931,21 @@
           <a:bodyPr wrap="none" lIns="0" tIns="0" rIns="0" bIns="0" rtlCol="0" anchor="ctr"/>
           <a:lstStyle/>
           <a:p>
-            <a:pPr rtl="1" algn="ctr" indent="0" marL="0">
+            <a:pPr algn="ctr" indent="0" marL="0">
               <a:buNone/>
             </a:pPr>
             <a:r>
-              <a:rPr lang="ar-SA" altLang="en-US" sz="3000" dirty="0">
+              <a:rPr lang="en-US" sz="2600" b="1" dirty="0">
                 <a:solidFill>
                   <a:srgbClr val="FFFFFF"/>
                 </a:solidFill>
-                <a:latin typeface="Traditional Arabic" pitchFamily="34" charset="0"/>
-                <a:ea typeface="Traditional Arabic" pitchFamily="34" charset="-122"/>
-                <a:cs typeface="Traditional Arabic" pitchFamily="34" charset="-120"/>
+                <a:latin typeface="Arial" pitchFamily="34" charset="0"/>
+                <a:ea typeface="Arial" pitchFamily="34" charset="-122"/>
+                <a:cs typeface="Arial" pitchFamily="34" charset="-120"/>
               </a:rPr>
-              <a:t>ألف واو الجماعة: نكتبها ولا نقرؤها</a:t>
+              <a:t>Same here: stop on the waw, skip the alif</a:t>
             </a:r>
-            <a:endParaRPr lang="ar-SA" sz="3000" dirty="0"/>
+            <a:endParaRPr lang="en-US" sz="2600" dirty="0"/>
           </a:p>
         </p:txBody>
       </p:sp>
@@ -18576,7 +18576,7 @@
         </p:nvSpPr>
         <p:spPr>
           <a:xfrm>
-            <a:off x="365760" y="914381"/>
+            <a:off x="365760" y="902716"/>
             <a:ext cx="8412480" cy="530352"/>
           </a:xfrm>
           <a:prstGeom prst="rect">
@@ -18589,21 +18589,21 @@
           <a:bodyPr wrap="none" lIns="0" tIns="0" rIns="0" bIns="0" rtlCol="0" anchor="ctr"/>
           <a:lstStyle/>
           <a:p>
-            <a:pPr rtl="1" algn="ctr" indent="0" marL="0">
+            <a:pPr algn="ctr" indent="0" marL="0">
               <a:buNone/>
             </a:pPr>
             <a:r>
-              <a:rPr lang="ar-SA" altLang="en-US" sz="2100" dirty="0">
+              <a:rPr lang="en-US" sz="2600" b="1" dirty="0">
                 <a:solidFill>
                   <a:srgbClr val="FFFFFF"/>
                 </a:solidFill>
-                <a:latin typeface="Traditional Arabic" pitchFamily="34" charset="0"/>
-                <a:ea typeface="Traditional Arabic" pitchFamily="34" charset="-122"/>
-                <a:cs typeface="Traditional Arabic" pitchFamily="34" charset="-120"/>
+                <a:latin typeface="Arial" pitchFamily="34" charset="0"/>
+                <a:ea typeface="Arial" pitchFamily="34" charset="-122"/>
+                <a:cs typeface="Arial" pitchFamily="34" charset="-120"/>
               </a:rPr>
-              <a:t>الدائرة الصغيرة: لا تُقرأ أبداً</a:t>
+              <a:t>Small circle: never read</a:t>
             </a:r>
-            <a:endParaRPr lang="ar-SA" sz="2100" dirty="0"/>
+            <a:endParaRPr lang="en-US" sz="2600" dirty="0"/>
           </a:p>
         </p:txBody>
       </p:sp>
@@ -18866,7 +18866,7 @@
         </p:nvSpPr>
         <p:spPr>
           <a:xfrm>
-            <a:off x="365760" y="3575685"/>
+            <a:off x="365760" y="3539744"/>
             <a:ext cx="8412480" cy="685800"/>
           </a:xfrm>
           <a:prstGeom prst="rect">
@@ -18879,21 +18879,21 @@
           <a:bodyPr wrap="none" lIns="0" tIns="0" rIns="0" bIns="0" rtlCol="0" anchor="ctr"/>
           <a:lstStyle/>
           <a:p>
-            <a:pPr rtl="1" algn="ctr" indent="0" marL="0">
+            <a:pPr algn="ctr" indent="0" marL="0">
               <a:buNone/>
             </a:pPr>
             <a:r>
-              <a:rPr lang="ar-SA" altLang="en-US" sz="3000" dirty="0">
+              <a:rPr lang="en-US" sz="2600" b="1" dirty="0">
                 <a:solidFill>
                   <a:srgbClr val="FFFFFF"/>
                 </a:solidFill>
-                <a:latin typeface="Traditional Arabic" pitchFamily="34" charset="0"/>
-                <a:ea typeface="Traditional Arabic" pitchFamily="34" charset="-122"/>
-                <a:cs typeface="Traditional Arabic" pitchFamily="34" charset="-120"/>
+                <a:latin typeface="Arial" pitchFamily="34" charset="0"/>
+                <a:ea typeface="Arial" pitchFamily="34" charset="-122"/>
+                <a:cs typeface="Arial" pitchFamily="34" charset="-120"/>
               </a:rPr>
-              <a:t>ألف «مِائَة»: لا تُقرأ، ونقرأ «مِئَة»</a:t>
+              <a:t>The alif of mi'ah (hundred) is not read</a:t>
             </a:r>
-            <a:endParaRPr lang="ar-SA" sz="3000" dirty="0"/>
+            <a:endParaRPr lang="en-US" sz="2600" dirty="0"/>
           </a:p>
         </p:txBody>
       </p:sp>
@@ -19484,7 +19484,7 @@
         </p:nvSpPr>
         <p:spPr>
           <a:xfrm>
-            <a:off x="365760" y="914381"/>
+            <a:off x="365760" y="902716"/>
             <a:ext cx="8412480" cy="530352"/>
           </a:xfrm>
           <a:prstGeom prst="rect">
@@ -19497,21 +19497,21 @@
           <a:bodyPr wrap="none" lIns="0" tIns="0" rIns="0" bIns="0" rtlCol="0" anchor="ctr"/>
           <a:lstStyle/>
           <a:p>
-            <a:pPr rtl="1" algn="ctr" indent="0" marL="0">
+            <a:pPr algn="ctr" indent="0" marL="0">
               <a:buNone/>
             </a:pPr>
             <a:r>
-              <a:rPr lang="ar-SA" altLang="en-US" sz="2100" dirty="0">
+              <a:rPr lang="en-US" sz="2600" b="1" dirty="0">
                 <a:solidFill>
                   <a:srgbClr val="FFFFFF"/>
                 </a:solidFill>
-                <a:latin typeface="Traditional Arabic" pitchFamily="34" charset="0"/>
-                <a:ea typeface="Traditional Arabic" pitchFamily="34" charset="-122"/>
-                <a:cs typeface="Traditional Arabic" pitchFamily="34" charset="-120"/>
+                <a:latin typeface="Arial" pitchFamily="34" charset="0"/>
+                <a:ea typeface="Arial" pitchFamily="34" charset="-122"/>
+                <a:cs typeface="Arial" pitchFamily="34" charset="-120"/>
               </a:rPr>
-              <a:t>الدائرة الصغيرة: لا تُقرأ أبداً</a:t>
+              <a:t>Small circle: never read</a:t>
             </a:r>
-            <a:endParaRPr lang="ar-SA" sz="2100" dirty="0"/>
+            <a:endParaRPr lang="en-US" sz="2600" dirty="0"/>
           </a:p>
         </p:txBody>
       </p:sp>
@@ -19774,7 +19774,7 @@
         </p:nvSpPr>
         <p:spPr>
           <a:xfrm>
-            <a:off x="365760" y="3555111"/>
+            <a:off x="365760" y="3539744"/>
             <a:ext cx="8412480" cy="685800"/>
           </a:xfrm>
           <a:prstGeom prst="rect">
@@ -19787,21 +19787,21 @@
           <a:bodyPr wrap="none" lIns="0" tIns="0" rIns="0" bIns="0" rtlCol="0" anchor="ctr"/>
           <a:lstStyle/>
           <a:p>
-            <a:pPr rtl="1" algn="ctr" indent="0" marL="0">
+            <a:pPr algn="ctr" indent="0" marL="0">
               <a:buNone/>
             </a:pPr>
             <a:r>
-              <a:rPr lang="ar-SA" altLang="en-US" sz="3000" dirty="0">
+              <a:rPr lang="en-US" sz="2600" b="1" dirty="0">
                 <a:solidFill>
                   <a:srgbClr val="FFFFFF"/>
                 </a:solidFill>
-                <a:latin typeface="Traditional Arabic" pitchFamily="34" charset="0"/>
-                <a:ea typeface="Traditional Arabic" pitchFamily="34" charset="-122"/>
-                <a:cs typeface="Traditional Arabic" pitchFamily="34" charset="-120"/>
+                <a:latin typeface="Arial" pitchFamily="34" charset="0"/>
+                <a:ea typeface="Arial" pitchFamily="34" charset="-122"/>
+                <a:cs typeface="Arial" pitchFamily="34" charset="-120"/>
               </a:rPr>
-              <a:t>وكذلك «مِائَتَيۡن»</a:t>
+              <a:t>Also mi'atayn (two hundred)</a:t>
             </a:r>
-            <a:endParaRPr lang="ar-SA" sz="3000" dirty="0"/>
+            <a:endParaRPr lang="en-US" sz="2600" dirty="0"/>
           </a:p>
         </p:txBody>
       </p:sp>
@@ -20582,7 +20582,7 @@
         </p:nvSpPr>
         <p:spPr>
           <a:xfrm>
-            <a:off x="365760" y="914381"/>
+            <a:off x="365760" y="902716"/>
             <a:ext cx="8412480" cy="530352"/>
           </a:xfrm>
           <a:prstGeom prst="rect">
@@ -20595,21 +20595,21 @@
           <a:bodyPr wrap="none" lIns="0" tIns="0" rIns="0" bIns="0" rtlCol="0" anchor="ctr"/>
           <a:lstStyle/>
           <a:p>
-            <a:pPr rtl="1" algn="ctr" indent="0" marL="0">
+            <a:pPr algn="ctr" indent="0" marL="0">
               <a:buNone/>
             </a:pPr>
             <a:r>
-              <a:rPr lang="ar-SA" altLang="en-US" sz="2100" dirty="0">
+              <a:rPr lang="en-US" sz="2600" b="1" dirty="0">
                 <a:solidFill>
                   <a:srgbClr val="FFFFFF"/>
                 </a:solidFill>
-                <a:latin typeface="Traditional Arabic" pitchFamily="34" charset="0"/>
-                <a:ea typeface="Traditional Arabic" pitchFamily="34" charset="-122"/>
-                <a:cs typeface="Traditional Arabic" pitchFamily="34" charset="-120"/>
+                <a:latin typeface="Arial" pitchFamily="34" charset="0"/>
+                <a:ea typeface="Arial" pitchFamily="34" charset="-122"/>
+                <a:cs typeface="Arial" pitchFamily="34" charset="-120"/>
               </a:rPr>
-              <a:t>الدائرة الصغيرة: لا تُقرأ أبداً</a:t>
+              <a:t>Small circle: never read</a:t>
             </a:r>
-            <a:endParaRPr lang="ar-SA" sz="2100" dirty="0"/>
+            <a:endParaRPr lang="en-US" sz="2600" dirty="0"/>
           </a:p>
         </p:txBody>
       </p:sp>
@@ -20872,7 +20872,7 @@
         </p:nvSpPr>
         <p:spPr>
           <a:xfrm>
-            <a:off x="365760" y="3594998"/>
+            <a:off x="365760" y="3539744"/>
             <a:ext cx="8412480" cy="685800"/>
           </a:xfrm>
           <a:prstGeom prst="rect">
@@ -20885,21 +20885,21 @@
           <a:bodyPr wrap="none" lIns="0" tIns="0" rIns="0" bIns="0" rtlCol="0" anchor="ctr"/>
           <a:lstStyle/>
           <a:p>
-            <a:pPr rtl="1" algn="ctr" indent="0" marL="0">
+            <a:pPr algn="ctr" indent="0" marL="0">
               <a:buNone/>
             </a:pPr>
             <a:r>
-              <a:rPr lang="ar-SA" altLang="en-US" sz="2300" dirty="0">
+              <a:rPr lang="en-US" sz="2600" b="1" dirty="0">
                 <a:solidFill>
                   <a:srgbClr val="FFFFFF"/>
                 </a:solidFill>
-                <a:latin typeface="Traditional Arabic" pitchFamily="34" charset="0"/>
-                <a:ea typeface="Traditional Arabic" pitchFamily="34" charset="-122"/>
-                <a:cs typeface="Traditional Arabic" pitchFamily="34" charset="-120"/>
+                <a:latin typeface="Arial" pitchFamily="34" charset="0"/>
+                <a:ea typeface="Arial" pitchFamily="34" charset="-122"/>
+                <a:cs typeface="Arial" pitchFamily="34" charset="-120"/>
               </a:rPr>
-              <a:t>الواو في «أُولَٰئِك» لا تُقرأ</a:t>
+              <a:t>The waw of ulaa'ika (those) is not read</a:t>
             </a:r>
-            <a:endParaRPr lang="ar-SA" sz="2300" dirty="0"/>
+            <a:endParaRPr lang="en-US" sz="2600" dirty="0"/>
           </a:p>
         </p:txBody>
       </p:sp>
@@ -21607,7 +21607,7 @@
         </p:nvSpPr>
         <p:spPr>
           <a:xfrm>
-            <a:off x="365760" y="914381"/>
+            <a:off x="365760" y="902716"/>
             <a:ext cx="8412480" cy="530352"/>
           </a:xfrm>
           <a:prstGeom prst="rect">
@@ -21620,21 +21620,21 @@
           <a:bodyPr wrap="none" lIns="0" tIns="0" rIns="0" bIns="0" rtlCol="0" anchor="ctr"/>
           <a:lstStyle/>
           <a:p>
-            <a:pPr rtl="1" algn="ctr" indent="0" marL="0">
+            <a:pPr algn="ctr" indent="0" marL="0">
               <a:buNone/>
             </a:pPr>
             <a:r>
-              <a:rPr lang="ar-SA" altLang="en-US" sz="2100" dirty="0">
+              <a:rPr lang="en-US" sz="2600" b="1" dirty="0">
                 <a:solidFill>
                   <a:srgbClr val="FFFFFF"/>
                 </a:solidFill>
-                <a:latin typeface="Traditional Arabic" pitchFamily="34" charset="0"/>
-                <a:ea typeface="Traditional Arabic" pitchFamily="34" charset="-122"/>
-                <a:cs typeface="Traditional Arabic" pitchFamily="34" charset="-120"/>
+                <a:latin typeface="Arial" pitchFamily="34" charset="0"/>
+                <a:ea typeface="Arial" pitchFamily="34" charset="-122"/>
+                <a:cs typeface="Arial" pitchFamily="34" charset="-120"/>
               </a:rPr>
-              <a:t>الدائرة الصغيرة: لا تُقرأ أبداً</a:t>
+              <a:t>Small circle: never read</a:t>
             </a:r>
-            <a:endParaRPr lang="ar-SA" sz="2100" dirty="0"/>
+            <a:endParaRPr lang="en-US" sz="2600" dirty="0"/>
           </a:p>
         </p:txBody>
       </p:sp>
@@ -21925,7 +21925,7 @@
         </p:nvSpPr>
         <p:spPr>
           <a:xfrm>
-            <a:off x="365760" y="3568065"/>
+            <a:off x="365760" y="3572002"/>
             <a:ext cx="8412480" cy="685800"/>
           </a:xfrm>
           <a:prstGeom prst="rect">
@@ -21938,21 +21938,21 @@
           <a:bodyPr wrap="none" lIns="0" tIns="0" rIns="0" bIns="0" rtlCol="0" anchor="ctr"/>
           <a:lstStyle/>
           <a:p>
-            <a:pPr rtl="1" algn="ctr" indent="0" marL="0">
+            <a:pPr algn="ctr" indent="0" marL="0">
               <a:buNone/>
             </a:pPr>
             <a:r>
-              <a:rPr lang="ar-SA" altLang="en-US" sz="3000" dirty="0">
+              <a:rPr lang="en-US" sz="2300" b="1" dirty="0">
                 <a:solidFill>
                   <a:srgbClr val="FFFFFF"/>
                 </a:solidFill>
-                <a:latin typeface="Traditional Arabic" pitchFamily="34" charset="0"/>
-                <a:ea typeface="Traditional Arabic" pitchFamily="34" charset="-122"/>
-                <a:cs typeface="Traditional Arabic" pitchFamily="34" charset="-120"/>
+                <a:latin typeface="Arial" pitchFamily="34" charset="0"/>
+                <a:ea typeface="Arial" pitchFamily="34" charset="-122"/>
+                <a:cs typeface="Arial" pitchFamily="34" charset="-120"/>
               </a:rPr>
-              <a:t>حرفان لا يُقرآن: الواو الأولى والألف بعد الواو</a:t>
+              <a:t>Two letters are not read: the first waw and the last alif</a:t>
             </a:r>
-            <a:endParaRPr lang="ar-SA" sz="3000" dirty="0"/>
+            <a:endParaRPr lang="en-US" sz="2300" dirty="0"/>
           </a:p>
         </p:txBody>
       </p:sp>
@@ -22533,7 +22533,7 @@
         </p:nvSpPr>
         <p:spPr>
           <a:xfrm>
-            <a:off x="365760" y="914381"/>
+            <a:off x="365760" y="902716"/>
             <a:ext cx="8412480" cy="530352"/>
           </a:xfrm>
           <a:prstGeom prst="rect">
@@ -22546,21 +22546,21 @@
           <a:bodyPr wrap="none" lIns="0" tIns="0" rIns="0" bIns="0" rtlCol="0" anchor="ctr"/>
           <a:lstStyle/>
           <a:p>
-            <a:pPr rtl="1" algn="ctr" indent="0" marL="0">
+            <a:pPr algn="ctr" indent="0" marL="0">
               <a:buNone/>
             </a:pPr>
             <a:r>
-              <a:rPr lang="ar-SA" altLang="en-US" sz="2100" dirty="0">
+              <a:rPr lang="en-US" sz="2600" b="1" dirty="0">
                 <a:solidFill>
                   <a:srgbClr val="FFFFFF"/>
                 </a:solidFill>
-                <a:latin typeface="Traditional Arabic" pitchFamily="34" charset="0"/>
-                <a:ea typeface="Traditional Arabic" pitchFamily="34" charset="-122"/>
-                <a:cs typeface="Traditional Arabic" pitchFamily="34" charset="-120"/>
+                <a:latin typeface="Arial" pitchFamily="34" charset="0"/>
+                <a:ea typeface="Arial" pitchFamily="34" charset="-122"/>
+                <a:cs typeface="Arial" pitchFamily="34" charset="-120"/>
               </a:rPr>
-              <a:t>الدائرة الصغيرة: لا تُقرأ أبداً</a:t>
+              <a:t>Small circle: never read</a:t>
             </a:r>
-            <a:endParaRPr lang="ar-SA" sz="2100" dirty="0"/>
+            <a:endParaRPr lang="en-US" sz="2600" dirty="0"/>
           </a:p>
         </p:txBody>
       </p:sp>
@@ -22823,7 +22823,7 @@
         </p:nvSpPr>
         <p:spPr>
           <a:xfrm>
-            <a:off x="365760" y="3554844"/>
+            <a:off x="365760" y="3539744"/>
             <a:ext cx="8412480" cy="685800"/>
           </a:xfrm>
           <a:prstGeom prst="rect">
@@ -22836,21 +22836,21 @@
           <a:bodyPr wrap="none" lIns="0" tIns="0" rIns="0" bIns="0" rtlCol="0" anchor="ctr"/>
           <a:lstStyle/>
           <a:p>
-            <a:pPr rtl="1" algn="ctr" indent="0" marL="0">
+            <a:pPr algn="ctr" indent="0" marL="0">
               <a:buNone/>
             </a:pPr>
             <a:r>
-              <a:rPr lang="ar-SA" altLang="en-US" sz="2700" dirty="0">
+              <a:rPr lang="en-US" sz="2600" b="1" dirty="0">
                 <a:solidFill>
                   <a:srgbClr val="FFFFFF"/>
                 </a:solidFill>
-                <a:latin typeface="Traditional Arabic" pitchFamily="34" charset="0"/>
-                <a:ea typeface="Traditional Arabic" pitchFamily="34" charset="-122"/>
-                <a:cs typeface="Traditional Arabic" pitchFamily="34" charset="-120"/>
+                <a:latin typeface="Arial" pitchFamily="34" charset="0"/>
+                <a:ea typeface="Arial" pitchFamily="34" charset="-122"/>
+                <a:cs typeface="Arial" pitchFamily="34" charset="-120"/>
               </a:rPr>
-              <a:t>ألف «لِشَا۟يۡءٍ» لا تُقرأ</a:t>
+              <a:t>The alif in li-shay'in is not read</a:t>
             </a:r>
-            <a:endParaRPr lang="ar-SA" sz="2700" dirty="0"/>
+            <a:endParaRPr lang="en-US" sz="2600" dirty="0"/>
           </a:p>
         </p:txBody>
       </p:sp>
@@ -23456,7 +23456,7 @@
         </p:nvSpPr>
         <p:spPr>
           <a:xfrm>
-            <a:off x="365760" y="914381"/>
+            <a:off x="365760" y="902716"/>
             <a:ext cx="8412480" cy="530352"/>
           </a:xfrm>
           <a:prstGeom prst="rect">
@@ -23469,21 +23469,21 @@
           <a:bodyPr wrap="none" lIns="0" tIns="0" rIns="0" bIns="0" rtlCol="0" anchor="ctr"/>
           <a:lstStyle/>
           <a:p>
-            <a:pPr rtl="1" algn="ctr" indent="0" marL="0">
+            <a:pPr algn="ctr" indent="0" marL="0">
               <a:buNone/>
             </a:pPr>
             <a:r>
-              <a:rPr lang="ar-SA" altLang="en-US" sz="2100" dirty="0">
+              <a:rPr lang="en-US" sz="2600" b="1" dirty="0">
                 <a:solidFill>
                   <a:srgbClr val="FFFFFF"/>
                 </a:solidFill>
-                <a:latin typeface="Traditional Arabic" pitchFamily="34" charset="0"/>
-                <a:ea typeface="Traditional Arabic" pitchFamily="34" charset="-122"/>
-                <a:cs typeface="Traditional Arabic" pitchFamily="34" charset="-120"/>
+                <a:latin typeface="Arial" pitchFamily="34" charset="0"/>
+                <a:ea typeface="Arial" pitchFamily="34" charset="-122"/>
+                <a:cs typeface="Arial" pitchFamily="34" charset="-120"/>
               </a:rPr>
-              <a:t>الدائرة الصغيرة: لا تُقرأ أبداً</a:t>
+              <a:t>Small circle: never read</a:t>
             </a:r>
-            <a:endParaRPr lang="ar-SA" sz="2100" dirty="0"/>
+            <a:endParaRPr lang="en-US" sz="2600" dirty="0"/>
           </a:p>
         </p:txBody>
       </p:sp>
@@ -23732,7 +23732,7 @@
         </p:nvSpPr>
         <p:spPr>
           <a:xfrm>
-            <a:off x="365760" y="3586353"/>
+            <a:off x="365760" y="3572764"/>
             <a:ext cx="8412480" cy="685800"/>
           </a:xfrm>
           <a:prstGeom prst="rect">
@@ -23745,21 +23745,21 @@
           <a:bodyPr wrap="none" lIns="0" tIns="0" rIns="0" bIns="0" rtlCol="0" anchor="ctr"/>
           <a:lstStyle/>
           <a:p>
-            <a:pPr rtl="1" algn="ctr" indent="0" marL="0">
+            <a:pPr algn="ctr" indent="0" marL="0">
               <a:buNone/>
             </a:pPr>
             <a:r>
-              <a:rPr lang="ar-SA" altLang="en-US" sz="3000" dirty="0">
+              <a:rPr lang="en-US" sz="2600" b="1" dirty="0">
                 <a:solidFill>
                   <a:srgbClr val="FFFFFF"/>
                 </a:solidFill>
-                <a:latin typeface="Traditional Arabic" pitchFamily="34" charset="0"/>
-                <a:ea typeface="Traditional Arabic" pitchFamily="34" charset="-122"/>
-                <a:cs typeface="Traditional Arabic" pitchFamily="34" charset="-120"/>
+                <a:latin typeface="Arial" pitchFamily="34" charset="0"/>
+                <a:ea typeface="Arial" pitchFamily="34" charset="-122"/>
+                <a:cs typeface="Arial" pitchFamily="34" charset="-120"/>
               </a:rPr>
-              <a:t>ألف «ثَمُودَا۟» لا تُقرأ</a:t>
+              <a:t>The alif of Thamooda is not read</a:t>
             </a:r>
-            <a:endParaRPr lang="ar-SA" sz="3000" dirty="0"/>
+            <a:endParaRPr lang="en-US" sz="2600" dirty="0"/>
           </a:p>
         </p:txBody>
       </p:sp>

</xml_diff>